<commit_message>
Phase 3: Regenerate presentation decks with labeled schematics/flowcharts and generate publication-quality multi-page PDF reports for both projects
</commit_message>
<xml_diff>
--- a/Project_2_Absorption_Chiller/Project2_Presentation.pptx
+++ b/Project_2_Absorption_Chiller/Project2_Presentation.pptx
@@ -3215,7 +3215,7 @@
               </a:defRPr>
             </a:pPr>
             <a:r>
-              <a:t>ME3160 — Power &amp; Refrigeration Cycles | Term Project 2</a:t>
+              <a:t>ME3160 — Power &amp; Refrigeration Systems | Final Project 2</a:t>
             </a:r>
           </a:p>
           <a:p>
@@ -3238,14 +3238,14 @@
               <a:spcBef>
                 <a:spcPts val="1400"/>
               </a:spcBef>
-              <a:defRPr sz="1500">
+              <a:defRPr sz="1400">
                 <a:solidFill>
                   <a:srgbClr val="CBD5E1"/>
                 </a:solidFill>
               </a:defRPr>
             </a:pPr>
             <a:r>
-              <a:t>Comprehensive Thermodynamic Analysis: Outdoor Air Psychrometrics → Chilled-Water Demand → Single-Effect Absorption Cycle → Industrial Flue-Gas Waste Heat Sizing</a:t>
+              <a:t>Comprehensive Thermodynamic Analysis: Zone Psychrometrics → District Cooling Demand → Ammonia Real-Gas EOS → Pátek &amp; Klomfar (1995) Solution Cycle → Industrial Flue-Gas Waste Heat Integration</a:t>
             </a:r>
           </a:p>
         </p:txBody>
@@ -3299,7 +3299,7 @@
               </a:defRPr>
             </a:pPr>
             <a:r>
-              <a:t>Key Specifications: 400 Zones (40 m² each) | 2 °C Evaporator / 7–12 °C Chilled Water | 300 °C Process Flue Gas | Peng-Robinson Real-Gas Ammonia EOS | Pátek &amp; Klomfar (1995) Mixtures</a:t>
+              <a:t>Key Specifications: 1,000 Zones (40 m² each) | 2 °C Evaporator / 7–12 °C Chilled Water | 300 °C Flue Gas | Peng-Robinson Real-Gas Ammonia EOS | Pátek &amp; Klomfar (1995) Binary Thermodynamics</a:t>
             </a:r>
           </a:p>
         </p:txBody>
@@ -3437,265 +3437,64 @@
           </a:p>
         </p:txBody>
       </p:sp>
-      <p:sp>
-        <p:nvSpPr>
-          <p:cNvPr id="5" name="Rounded Rectangle 4"/>
+      <p:pic>
+        <p:nvPicPr>
+          <p:cNvPr id="5" name="Picture 4" descr="schematic_cycle_p2.png"/>
+          <p:cNvPicPr>
+            <a:picLocks noChangeAspect="1"/>
+          </p:cNvPicPr>
+          <p:nvPr/>
+        </p:nvPicPr>
+        <p:blipFill>
+          <a:blip r:embed="rId2"/>
+          <a:stretch>
+            <a:fillRect/>
+          </a:stretch>
+        </p:blipFill>
+        <p:spPr>
+          <a:xfrm>
+            <a:off x="731520" y="1097280"/>
+            <a:ext cx="5212080" cy="3648456"/>
+          </a:xfrm>
+          <a:prstGeom prst="rect">
+            <a:avLst/>
+          </a:prstGeom>
+        </p:spPr>
+      </p:pic>
+      <p:pic>
+        <p:nvPicPr>
+          <p:cNvPr id="6" name="Picture 5" descr="schematic_ahu_p2.png"/>
+          <p:cNvPicPr>
+            <a:picLocks noChangeAspect="1"/>
+          </p:cNvPicPr>
+          <p:nvPr/>
+        </p:nvPicPr>
+        <p:blipFill>
+          <a:blip r:embed="rId3"/>
+          <a:stretch>
+            <a:fillRect/>
+          </a:stretch>
+        </p:blipFill>
+        <p:spPr>
+          <a:xfrm>
+            <a:off x="6217920" y="1097280"/>
+            <a:ext cx="5212080" cy="3387852"/>
+          </a:xfrm>
+          <a:prstGeom prst="rect">
+            <a:avLst/>
+          </a:prstGeom>
+        </p:spPr>
+      </p:pic>
+      <p:sp>
+        <p:nvSpPr>
+          <p:cNvPr id="7" name="Rounded Rectangle 6"/>
           <p:cNvSpPr/>
           <p:nvPr/>
         </p:nvSpPr>
         <p:spPr>
           <a:xfrm>
-            <a:off x="731520" y="1188720"/>
-            <a:ext cx="5212080" cy="5303520"/>
-          </a:xfrm>
-          <a:prstGeom prst="roundRect">
-            <a:avLst/>
-          </a:prstGeom>
-          <a:solidFill>
-            <a:srgbClr val="F1F5F9"/>
-          </a:solidFill>
-          <a:ln>
-            <a:solidFill>
-              <a:srgbClr val="355F8E"/>
-            </a:solidFill>
-          </a:ln>
-        </p:spPr>
-        <p:style>
-          <a:lnRef idx="1">
-            <a:schemeClr val="accent1"/>
-          </a:lnRef>
-          <a:fillRef idx="3">
-            <a:schemeClr val="accent1"/>
-          </a:fillRef>
-          <a:effectRef idx="2">
-            <a:schemeClr val="accent1"/>
-          </a:effectRef>
-          <a:fontRef idx="minor">
-            <a:schemeClr val="lt1"/>
-          </a:fontRef>
-        </p:style>
-        <p:txBody>
-          <a:bodyPr rtlCol="0" anchor="ctr" wrap="square"/>
-          <a:lstStyle/>
-          <a:p>
-            <a:pPr algn="ctr">
-              <a:defRPr sz="1500" b="1">
-                <a:solidFill>
-                  <a:srgbClr val="102C57"/>
-                </a:solidFill>
-              </a:defRPr>
-            </a:pPr>
-            <a:r>
-              <a:t>(a) Single-Effect Ammonia-Water Chiller Network</a:t>
-            </a:r>
-          </a:p>
-          <a:p>
-            <a:pPr>
-              <a:spcBef>
-                <a:spcPts val="400"/>
-              </a:spcBef>
-              <a:defRPr sz="1050">
-                <a:solidFill>
-                  <a:srgbClr val="212529"/>
-                </a:solidFill>
-              </a:defRPr>
-            </a:pPr>
-            <a:r>
-              <a:t>• State 1: Strong solution leaving absorber (Tabs, Plow, x_strong)</a:t>
-            </a:r>
-          </a:p>
-          <a:p>
-            <a:pPr>
-              <a:spcBef>
-                <a:spcPts val="400"/>
-              </a:spcBef>
-              <a:defRPr sz="1050">
-                <a:solidFill>
-                  <a:srgbClr val="212529"/>
-                </a:solidFill>
-              </a:defRPr>
-            </a:pPr>
-            <a:r>
-              <a:t>• State 2: Strong solution leaving pump (P_high, W_pump, η=70%)</a:t>
-            </a:r>
-          </a:p>
-          <a:p>
-            <a:pPr>
-              <a:spcBef>
-                <a:spcPts val="400"/>
-              </a:spcBef>
-              <a:defRPr sz="1050">
-                <a:solidFill>
-                  <a:srgbClr val="212529"/>
-                </a:solidFill>
-              </a:defRPr>
-            </a:pPr>
-            <a:r>
-              <a:t>• State 3: Strong solution after SHX entering generator (T3, P_high)</a:t>
-            </a:r>
-          </a:p>
-          <a:p>
-            <a:pPr>
-              <a:spcBef>
-                <a:spcPts val="400"/>
-              </a:spcBef>
-              <a:defRPr sz="1050">
-                <a:solidFill>
-                  <a:srgbClr val="212529"/>
-                </a:solidFill>
-              </a:defRPr>
-            </a:pPr>
-            <a:r>
-              <a:t>• State 4: Weak solution leaving generator (Tgen=130 °C, P_high, x_weak)</a:t>
-            </a:r>
-          </a:p>
-          <a:p>
-            <a:pPr>
-              <a:spcBef>
-                <a:spcPts val="400"/>
-              </a:spcBef>
-              <a:defRPr sz="1050">
-                <a:solidFill>
-                  <a:srgbClr val="212529"/>
-                </a:solidFill>
-              </a:defRPr>
-            </a:pPr>
-            <a:r>
-              <a:t>• State 5: Weak solution cooled in SHX (T5, P_high, ε_SHX=70%)</a:t>
-            </a:r>
-          </a:p>
-          <a:p>
-            <a:pPr>
-              <a:spcBef>
-                <a:spcPts val="400"/>
-              </a:spcBef>
-              <a:defRPr sz="1050">
-                <a:solidFill>
-                  <a:srgbClr val="212529"/>
-                </a:solidFill>
-              </a:defRPr>
-            </a:pPr>
-            <a:r>
-              <a:t>• State 6: Weak solution throttled into absorber (h6 = h5, Plow)</a:t>
-            </a:r>
-          </a:p>
-          <a:p>
-            <a:pPr>
-              <a:spcBef>
-                <a:spcPts val="400"/>
-              </a:spcBef>
-              <a:defRPr sz="1050">
-                <a:solidFill>
-                  <a:srgbClr val="212529"/>
-                </a:solidFill>
-              </a:defRPr>
-            </a:pPr>
-            <a:r>
-              <a:t>• State 7: High-purity vapor leaving rectifier (T_dew, y_r = 99.5%)</a:t>
-            </a:r>
-          </a:p>
-          <a:p>
-            <a:pPr>
-              <a:spcBef>
-                <a:spcPts val="400"/>
-              </a:spcBef>
-              <a:defRPr sz="1050">
-                <a:solidFill>
-                  <a:srgbClr val="212529"/>
-                </a:solidFill>
-              </a:defRPr>
-            </a:pPr>
-            <a:r>
-              <a:t>• State 8: Saturated liquid leaving condenser (Tcond, P_high)</a:t>
-            </a:r>
-          </a:p>
-          <a:p>
-            <a:pPr>
-              <a:spcBef>
-                <a:spcPts val="400"/>
-              </a:spcBef>
-              <a:defRPr sz="1050">
-                <a:solidFill>
-                  <a:srgbClr val="212529"/>
-                </a:solidFill>
-              </a:defRPr>
-            </a:pPr>
-            <a:r>
-              <a:t>• State 9: Two-phase refrigerant after expansion valve (h9 = h8, Plow)</a:t>
-            </a:r>
-          </a:p>
-          <a:p>
-            <a:pPr>
-              <a:spcBef>
-                <a:spcPts val="400"/>
-              </a:spcBef>
-              <a:defRPr sz="1050">
-                <a:solidFill>
-                  <a:srgbClr val="212529"/>
-                </a:solidFill>
-              </a:defRPr>
-            </a:pPr>
-            <a:r>
-              <a:t>• State 10: Saturated vapor leaving evaporator (Tevap=2 °C, Plow)</a:t>
-            </a:r>
-          </a:p>
-          <a:p>
-            <a:pPr>
-              <a:spcBef>
-                <a:spcPts val="400"/>
-              </a:spcBef>
-              <a:defRPr sz="1050">
-                <a:solidFill>
-                  <a:srgbClr val="212529"/>
-                </a:solidFill>
-              </a:defRPr>
-            </a:pPr>
-            <a:r>
-              <a:t>• State 11: Refrigerant vapor entering absorber (combines with weak sol)</a:t>
-            </a:r>
-          </a:p>
-          <a:p>
-            <a:pPr>
-              <a:spcBef>
-                <a:spcPts val="400"/>
-              </a:spcBef>
-              <a:defRPr sz="1050">
-                <a:solidFill>
-                  <a:srgbClr val="212529"/>
-                </a:solidFill>
-              </a:defRPr>
-            </a:pPr>
-            <a:r>
-              <a:t>• Waste Heat Stream: Process flue gas (300 °C in, ε=0.75, ≥140 °C floor)</a:t>
-            </a:r>
-          </a:p>
-          <a:p>
-            <a:pPr>
-              <a:spcBef>
-                <a:spcPts val="400"/>
-              </a:spcBef>
-              <a:defRPr sz="1050">
-                <a:solidFill>
-                  <a:srgbClr val="212529"/>
-                </a:solidFill>
-              </a:defRPr>
-            </a:pPr>
-            <a:r>
-              <a:t>• Cooling Water Loop: Cooled by Evaporative Condenser (Tabs = Tcond)</a:t>
-            </a:r>
-          </a:p>
-        </p:txBody>
-      </p:sp>
-      <p:sp>
-        <p:nvSpPr>
-          <p:cNvPr id="6" name="Rounded Rectangle 5"/>
-          <p:cNvSpPr/>
-          <p:nvPr/>
-        </p:nvSpPr>
-        <p:spPr>
-          <a:xfrm>
-            <a:off x="6217920" y="1188720"/>
-            <a:ext cx="5212080" cy="5303520"/>
+            <a:off x="731520" y="5577840"/>
+            <a:ext cx="10728655" cy="960120"/>
           </a:xfrm>
           <a:prstGeom prst="roundRect">
             <a:avLst/>
@@ -3728,194 +3527,26 @@
           <a:lstStyle/>
           <a:p>
             <a:pPr algn="ctr">
-              <a:defRPr sz="1500" b="1">
+              <a:defRPr sz="1100" b="1">
                 <a:solidFill>
                   <a:srgbClr val="102C57"/>
                 </a:solidFill>
               </a:defRPr>
             </a:pPr>
             <a:r>
-              <a:t>(b) Zone Air Handling Unit (AHU) &amp; Drainage Network</a:t>
+              <a:t>Diagrammatic Key &amp; Thermodynamic Interfaces:</a:t>
             </a:r>
           </a:p>
           <a:p>
             <a:pPr>
-              <a:spcBef>
-                <a:spcPts val="400"/>
-              </a:spcBef>
-              <a:defRPr sz="1050">
+              <a:defRPr sz="950">
                 <a:solidFill>
                   <a:srgbClr val="212529"/>
                 </a:solidFill>
               </a:defRPr>
             </a:pPr>
             <a:r>
-              <a:t>• State OA: Outdoor fresh air (T_oa, RH_oa, Twb_oa, w_oa)</a:t>
-            </a:r>
-          </a:p>
-          <a:p>
-            <a:pPr>
-              <a:spcBef>
-                <a:spcPts val="400"/>
-              </a:spcBef>
-              <a:defRPr sz="1050">
-                <a:solidFill>
-                  <a:srgbClr val="212529"/>
-                </a:solidFill>
-              </a:defRPr>
-            </a:pPr>
-            <a:r>
-              <a:t>• State RA: Recirculated room air (T_room = 22.0 °C, w_room, RH_room)</a:t>
-            </a:r>
-          </a:p>
-          <a:p>
-            <a:pPr>
-              <a:spcBef>
-                <a:spcPts val="400"/>
-              </a:spcBef>
-              <a:defRPr sz="1050">
-                <a:solidFill>
-                  <a:srgbClr val="212529"/>
-                </a:solidFill>
-              </a:defRPr>
-            </a:pPr>
-            <a:r>
-              <a:t>• State MIX: Adiabatic mixing chamber (70% RA + 30% OA by dry air)</a:t>
-            </a:r>
-          </a:p>
-          <a:p>
-            <a:pPr>
-              <a:spcBef>
-                <a:spcPts val="400"/>
-              </a:spcBef>
-              <a:defRPr sz="1050">
-                <a:solidFill>
-                  <a:srgbClr val="212529"/>
-                </a:solidFill>
-              </a:defRPr>
-            </a:pPr>
-            <a:r>
-              <a:t>• State ADP: Apparatus Dew Point on coil cooling fins (saturated w_adp)</a:t>
-            </a:r>
-          </a:p>
-          <a:p>
-            <a:pPr>
-              <a:spcBef>
-                <a:spcPts val="400"/>
-              </a:spcBef>
-              <a:defRPr sz="1050">
-                <a:solidFill>
-                  <a:srgbClr val="212529"/>
-                </a:solidFill>
-              </a:defRPr>
-            </a:pPr>
-            <a:r>
-              <a:t>• State SUP: Supply air leaving coil: T_sup = ADP + BF·(T_mix - ADP)</a:t>
-            </a:r>
-          </a:p>
-          <a:p>
-            <a:pPr>
-              <a:spcBef>
-                <a:spcPts val="400"/>
-              </a:spcBef>
-              <a:defRPr sz="1050">
-                <a:solidFill>
-                  <a:srgbClr val="212529"/>
-                </a:solidFill>
-              </a:defRPr>
-            </a:pPr>
-            <a:r>
-              <a:t>• Bypass Factor: BF = 0.15 (15% air bypasses, 85% contacts ADP)</a:t>
-            </a:r>
-          </a:p>
-          <a:p>
-            <a:pPr>
-              <a:spcBef>
-                <a:spcPts val="400"/>
-              </a:spcBef>
-              <a:defRPr sz="1050">
-                <a:solidFill>
-                  <a:srgbClr val="212529"/>
-                </a:solidFill>
-              </a:defRPr>
-            </a:pPr>
-            <a:r>
-              <a:t>• Room Setpoint: Dry bulb held strictly at 22.0 °C; RH ≤ 75% ceiling</a:t>
-            </a:r>
-          </a:p>
-          <a:p>
-            <a:pPr>
-              <a:spcBef>
-                <a:spcPts val="400"/>
-              </a:spcBef>
-              <a:defRPr sz="1050">
-                <a:solidFill>
-                  <a:srgbClr val="212529"/>
-                </a:solidFill>
-              </a:defRPr>
-            </a:pPr>
-            <a:r>
-              <a:t>• Drain Pan &amp; Trap: Condensate collected at coil ADP: h_cond = hf(ADP)</a:t>
-            </a:r>
-          </a:p>
-          <a:p>
-            <a:pPr>
-              <a:spcBef>
-                <a:spcPts val="400"/>
-              </a:spcBef>
-              <a:defRPr sz="1050">
-                <a:solidFill>
-                  <a:srgbClr val="212529"/>
-                </a:solidFill>
-              </a:defRPr>
-            </a:pPr>
-            <a:r>
-              <a:t>• Central Decanter: 400 zones drain to central holding tank for reuse</a:t>
-            </a:r>
-          </a:p>
-          <a:p>
-            <a:pPr>
-              <a:spcBef>
-                <a:spcPts val="400"/>
-              </a:spcBef>
-              <a:defRPr sz="1050">
-                <a:solidFill>
-                  <a:srgbClr val="212529"/>
-                </a:solidFill>
-              </a:defRPr>
-            </a:pPr>
-            <a:r>
-              <a:t>• Chilled Water Interface: 7 °C supply / 12 °C return to chiller evaporator</a:t>
-            </a:r>
-          </a:p>
-          <a:p>
-            <a:pPr>
-              <a:spcBef>
-                <a:spcPts val="400"/>
-              </a:spcBef>
-              <a:defRPr sz="1050">
-                <a:solidFill>
-                  <a:srgbClr val="212529"/>
-                </a:solidFill>
-              </a:defRPr>
-            </a:pPr>
-            <a:r>
-              <a:t>• District Scale: N = 400 zones, +5% distribution gain, +2% pump gain</a:t>
-            </a:r>
-          </a:p>
-          <a:p>
-            <a:pPr>
-              <a:spcBef>
-                <a:spcPts val="400"/>
-              </a:spcBef>
-              <a:defRPr sz="1050">
-                <a:solidFill>
-                  <a:srgbClr val="212529"/>
-                </a:solidFill>
-              </a:defRPr>
-            </a:pPr>
-            <a:r>
-              <a:t>• Governing Load Logic: Sensible envelope + solar + internal gains</a:t>
+              <a:t>(a) Cycle: Numbered states 1 to 10 show strong/weak solution circulation, SHX recuperation (ε=0.70), rectifier reflux balance, and industrial flue-gas heating (300 °C in → 155–169 °C out). (b) AHU: Fresh outdoor air (30%) mixes with recirculated room air (70%), dehumidifies on cooling coil fins at ADP, and drains condensate to central decanter.</a:t>
             </a:r>
           </a:p>
         </p:txBody>
@@ -4048,21 +3679,45 @@
               </a:defRPr>
             </a:pPr>
             <a:r>
-              <a:t>Computational Algorithm: Multi-Tiered Solver Architecture</a:t>
-            </a:r>
-          </a:p>
-        </p:txBody>
-      </p:sp>
-      <p:sp>
-        <p:nvSpPr>
-          <p:cNvPr id="5" name="Rounded Rectangle 4"/>
+              <a:t>Computational Algorithm: Multi-Tiered Solver Architecture &amp; Flowchart</a:t>
+            </a:r>
+          </a:p>
+        </p:txBody>
+      </p:sp>
+      <p:pic>
+        <p:nvPicPr>
+          <p:cNvPr id="5" name="Picture 4" descr="flowchart_algorithm_p2.png"/>
+          <p:cNvPicPr>
+            <a:picLocks noChangeAspect="1"/>
+          </p:cNvPicPr>
+          <p:nvPr/>
+        </p:nvPicPr>
+        <p:blipFill>
+          <a:blip r:embed="rId2"/>
+          <a:stretch>
+            <a:fillRect/>
+          </a:stretch>
+        </p:blipFill>
+        <p:spPr>
+          <a:xfrm>
+            <a:off x="731520" y="1097280"/>
+            <a:ext cx="6583680" cy="4279392"/>
+          </a:xfrm>
+          <a:prstGeom prst="rect">
+            <a:avLst/>
+          </a:prstGeom>
+        </p:spPr>
+      </p:pic>
+      <p:sp>
+        <p:nvSpPr>
+          <p:cNvPr id="6" name="Rounded Rectangle 5"/>
           <p:cNvSpPr/>
           <p:nvPr/>
         </p:nvSpPr>
         <p:spPr>
           <a:xfrm>
-            <a:off x="731520" y="1188720"/>
-            <a:ext cx="10728655" cy="1645920"/>
+            <a:off x="7498079" y="1097280"/>
+            <a:ext cx="3962095" cy="5440680"/>
           </a:xfrm>
           <a:prstGeom prst="roundRect">
             <a:avLst/>
@@ -4102,228 +3757,67 @@
               </a:defRPr>
             </a:pPr>
             <a:r>
-              <a:t>Tier 1: Zone Psychrometric &amp; Moisture Balance Loop</a:t>
+              <a:t>Methodological Highlights:</a:t>
             </a:r>
           </a:p>
           <a:p>
             <a:pPr>
               <a:spcBef>
-                <a:spcPts val="300"/>
+                <a:spcPts val="600"/>
               </a:spcBef>
-              <a:defRPr sz="1000">
+              <a:defRPr sz="950">
                 <a:solidFill>
                   <a:srgbClr val="212529"/>
                 </a:solidFill>
               </a:defRPr>
             </a:pPr>
             <a:r>
-              <a:t>1. Input ambient (T_oa, RH_oa) and calculate w_oa and Twb via adiabatic saturation.</a:t>
-            </a:r>
-            <a:br/>
-            <a:r>
-              <a:t>2. Compute sensible room load: Q_sens = UA_env·(T_oa - 22) + Q_solar + 1100 W.</a:t>
-            </a:r>
-            <a:br/>
-            <a:r>
-              <a:t>3. Determine required supply temperature: T_sup = 22 - Q_sens / (m_da · Cp_air).</a:t>
-            </a:r>
-            <a:br/>
-            <a:r>
-              <a:t>4. Guess room humidity ratio w_room; calculate mixed state (T_mix, w_mix).</a:t>
-            </a:r>
-            <a:br/>
-            <a:r>
-              <a:t>5. Invert coil relation for ADP = (T_sup - BF·T_mix) / (1 - BF) and w_adp = w_sat(ADP).</a:t>
-            </a:r>
-            <a:br/>
-            <a:r>
-              <a:t>6. Calculate w_sup = w_adp + BF·(w_mix - w_adp) and room update w_room = w_sup + m_w_int/m_da.</a:t>
-            </a:r>
-            <a:br/>
-            <a:r>
-              <a:t>7. Iterate until |w_room^(k+1) - w_room^(k)| &lt; 1e-8. Verify RH_room ≤ 75%.</a:t>
-            </a:r>
-          </a:p>
-        </p:txBody>
-      </p:sp>
-      <p:sp>
-        <p:nvSpPr>
-          <p:cNvPr id="6" name="Rounded Rectangle 5"/>
-          <p:cNvSpPr/>
-          <p:nvPr/>
-        </p:nvSpPr>
-        <p:spPr>
-          <a:xfrm>
-            <a:off x="731520" y="2971800"/>
-            <a:ext cx="10728655" cy="1645920"/>
-          </a:xfrm>
-          <a:prstGeom prst="roundRect">
-            <a:avLst/>
-          </a:prstGeom>
-          <a:solidFill>
-            <a:srgbClr val="F1F5F9"/>
-          </a:solidFill>
-          <a:ln>
-            <a:solidFill>
-              <a:srgbClr val="355F8E"/>
-            </a:solidFill>
-          </a:ln>
-        </p:spPr>
-        <p:style>
-          <a:lnRef idx="1">
-            <a:schemeClr val="accent1"/>
-          </a:lnRef>
-          <a:fillRef idx="3">
-            <a:schemeClr val="accent1"/>
-          </a:fillRef>
-          <a:effectRef idx="2">
-            <a:schemeClr val="accent1"/>
-          </a:effectRef>
-          <a:fontRef idx="minor">
-            <a:schemeClr val="lt1"/>
-          </a:fontRef>
-        </p:style>
-        <p:txBody>
-          <a:bodyPr rtlCol="0" anchor="ctr" wrap="square"/>
-          <a:lstStyle/>
-          <a:p>
-            <a:pPr algn="ctr">
-              <a:defRPr sz="1300" b="1">
-                <a:solidFill>
-                  <a:srgbClr val="102C57"/>
-                </a:solidFill>
-              </a:defRPr>
-            </a:pPr>
-            <a:r>
-              <a:t>Tier 2: Real-Gas &amp; Mixture Property Engines</a:t>
+              <a:t>• Tier 1 Psychrometric Iteration: Rigorous moisture balance solves room humidity ratio w_room and coil ADP simultaneously; accounts for water-vapor condensate enthalpy removal.</a:t>
             </a:r>
           </a:p>
           <a:p>
             <a:pPr>
               <a:spcBef>
-                <a:spcPts val="300"/>
+                <a:spcPts val="600"/>
               </a:spcBef>
-              <a:defRPr sz="1000">
+              <a:defRPr sz="950">
                 <a:solidFill>
                   <a:srgbClr val="212529"/>
                 </a:solidFill>
               </a:defRPr>
             </a:pPr>
             <a:r>
-              <a:t>• Pure Ammonia: Peng-Robinson cubic EOS with Lee-Kesler acentric factor correlation.</a:t>
-            </a:r>
-            <a:br/>
-            <a:r>
-              <a:t>• Reference State: T_ref = 273.15 K, P_ref = 101.325 kPa, ideal gas href = 0, sref = 0.</a:t>
-            </a:r>
-            <a:br/>
-            <a:r>
-              <a:t>• Mixture Phase Equilibrium: Pátek &amp; Klomfar (1995) explicit polynomial series.</a:t>
-            </a:r>
-            <a:br/>
-            <a:r>
-              <a:t>  - Table 1: T_bub(p, x) = T0 · Σ a_i (1-x)^m_i [ln(p0/p)]^n_i  (Row 13: 4.895960E+00)</a:t>
-            </a:r>
-            <a:br/>
-            <a:r>
-              <a:t>  - Table 2: T_dew(p, y) = T0 · Σ a_i (1-y)^(m_i/4) [ln(p0/p)]^n_i</a:t>
-            </a:r>
-            <a:br/>
-            <a:r>
-              <a:t>• Solution Enthalpies: Saturated liquid h_L(T, x) and saturated vapor h_V(T, y) with heat of solution.</a:t>
-            </a:r>
-          </a:p>
-        </p:txBody>
-      </p:sp>
-      <p:sp>
-        <p:nvSpPr>
-          <p:cNvPr id="7" name="Rounded Rectangle 6"/>
-          <p:cNvSpPr/>
-          <p:nvPr/>
-        </p:nvSpPr>
-        <p:spPr>
-          <a:xfrm>
-            <a:off x="731520" y="4754880"/>
-            <a:ext cx="10728655" cy="1645920"/>
-          </a:xfrm>
-          <a:prstGeom prst="roundRect">
-            <a:avLst/>
-          </a:prstGeom>
-          <a:solidFill>
-            <a:srgbClr val="F1F5F9"/>
-          </a:solidFill>
-          <a:ln>
-            <a:solidFill>
-              <a:srgbClr val="355F8E"/>
-            </a:solidFill>
-          </a:ln>
-        </p:spPr>
-        <p:style>
-          <a:lnRef idx="1">
-            <a:schemeClr val="accent1"/>
-          </a:lnRef>
-          <a:fillRef idx="3">
-            <a:schemeClr val="accent1"/>
-          </a:fillRef>
-          <a:effectRef idx="2">
-            <a:schemeClr val="accent1"/>
-          </a:effectRef>
-          <a:fontRef idx="minor">
-            <a:schemeClr val="lt1"/>
-          </a:fontRef>
-        </p:style>
-        <p:txBody>
-          <a:bodyPr rtlCol="0" anchor="ctr" wrap="square"/>
-          <a:lstStyle/>
-          <a:p>
-            <a:pPr algn="ctr">
-              <a:defRPr sz="1300" b="1">
-                <a:solidFill>
-                  <a:srgbClr val="102C57"/>
-                </a:solidFill>
-              </a:defRPr>
-            </a:pPr>
-            <a:r>
-              <a:t>Tier 3: Absorption Cycle &amp; Condenser Closed-Loop Solver</a:t>
+              <a:t>• Tier 2 Mixture Physics: Complete implementation of Pátek &amp; Klomfar (1995) Table 1 (bubble point) and Table 2 (dew point), with unified 0 °C ideal-gas enthalpy scale matching Peng-Robinson EOS departures.</a:t>
             </a:r>
           </a:p>
           <a:p>
             <a:pPr>
               <a:spcBef>
-                <a:spcPts val="300"/>
+                <a:spcPts val="600"/>
               </a:spcBef>
-              <a:defRPr sz="1000">
+              <a:defRPr sz="950">
                 <a:solidFill>
                   <a:srgbClr val="212529"/>
                 </a:solidFill>
               </a:defRPr>
             </a:pPr>
             <a:r>
-              <a:t>1. Evaluate P_low = Psat(T_evap=2 °C) and P_high = Psat(T_cond).</a:t>
-            </a:r>
-            <a:br/>
-            <a:r>
-              <a:t>2. Invert T_bub to obtain equilibrium concentrations x_strong(Tabs, Plow) and x_weak(Tgen, Phigh).</a:t>
-            </a:r>
-            <a:br/>
-            <a:r>
-              <a:t>3. Circulation ratio f = (0.995 - x_weak) / (x_strong - x_weak); m_r = Q_evap / (h10 - h8).</a:t>
-            </a:r>
-            <a:br/>
-            <a:r>
-              <a:t>4. Solution heat exchanger (SHX) duty: Q_SHX = ε_SHX · m_weak · (h4 - h4@Tabs).</a:t>
-            </a:r>
-            <a:br/>
-            <a:r>
-              <a:t>5. Generator heat: Q_gen = m_r·h7 + m_weak·h4 - m_strong·h3 + Q_rect.</a:t>
-            </a:r>
-            <a:br/>
-            <a:r>
-              <a:t>6. Evaporative condenser off-design loop: balance Q_cond(T_cond) = UA · LMTD(T_cond, Twb).</a:t>
-            </a:r>
-            <a:br/>
-            <a:r>
-              <a:t>7. Check constraints: P_high ≤ 20 bar, T_cond ≥ 25 °C, m_fg ≤ 80 kg/s, turndown ≥ 25%.</a:t>
+              <a:t>• Tier 3 Closed-Loop Cycle: Fixed UA evaporative condenser balances heat rejection against ambient wet-bulb with air-side energy balance. Dynamic generator temperature T_gen tracks condensing pressure.</a:t>
+            </a:r>
+          </a:p>
+          <a:p>
+            <a:pPr>
+              <a:spcBef>
+                <a:spcPts val="600"/>
+              </a:spcBef>
+              <a:defRPr sz="950">
+                <a:solidFill>
+                  <a:srgbClr val="212529"/>
+                </a:solidFill>
+              </a:defRPr>
+            </a:pPr>
+            <a:r>
+              <a:t>• Rectifier Reflux Physics: Full mass and species balance on reflux column eliminates artificial fudge factors, yielding rigorous energy closure (&lt;0.0001 kW residual).</a:t>
             </a:r>
           </a:p>
         </p:txBody>
@@ -4456,7 +3950,7 @@
               </a:defRPr>
             </a:pPr>
             <a:r>
-              <a:t>Model Verification: Zero-Tolerance Hand-Traceable Checks (Checks 1 to 3)</a:t>
+              <a:t>Validation Suite: Automated Assertions Across Checks 1 to 3</a:t>
             </a:r>
           </a:p>
         </p:txBody>
@@ -4470,8 +3964,8 @@
           <p:nvPr/>
         </p:nvGraphicFramePr>
         <p:xfrm>
-          <a:off x="731520" y="1143000"/>
-          <a:ext cx="10728655" cy="5303520"/>
+          <a:off x="731520" y="1097280"/>
+          <a:ext cx="10698480" cy="5303520"/>
         </p:xfrm>
         <a:graphic>
           <a:graphicData uri="http://schemas.openxmlformats.org/drawingml/2006/table">
@@ -4480,27 +3974,27 @@
                 <a:tableStyleId>{5C22544A-7EE6-4342-B048-85BDC9FD1C3A}</a:tableStyleId>
               </a:tblPr>
               <a:tblGrid>
-                <a:gridCol w="3291840"/>
+                <a:gridCol w="3840480"/>
+                <a:gridCol w="1645920"/>
+                <a:gridCol w="1645920"/>
                 <a:gridCol w="1828800"/>
-                <a:gridCol w="1828800"/>
-                <a:gridCol w="1828800"/>
-                <a:gridCol w="1950415"/>
+                <a:gridCol w="1737360"/>
               </a:tblGrid>
-              <a:tr h="230587">
-                <a:tc>
-                  <a:txBody>
-                    <a:bodyPr/>
-                    <a:lstStyle/>
-                    <a:p>
-                      <a:pPr>
-                        <a:defRPr sz="1000" b="1">
+              <a:tr h="279132">
+                <a:tc>
+                  <a:txBody>
+                    <a:bodyPr/>
+                    <a:lstStyle/>
+                    <a:p>
+                      <a:pPr>
+                        <a:defRPr sz="950" b="1">
                           <a:solidFill>
                             <a:srgbClr val="FFFFFF"/>
                           </a:solidFill>
                         </a:defRPr>
                       </a:pPr>
                       <a:r>
-                        <a:t>Validation Parameter</a:t>
+                        <a:t>Quantity / Verification Parameter</a:t>
                       </a:r>
                     </a:p>
                   </a:txBody>
@@ -4516,14 +4010,14 @@
                     <a:lstStyle/>
                     <a:p>
                       <a:pPr>
-                        <a:defRPr sz="1000" b="1">
+                        <a:defRPr sz="950" b="1">
                           <a:solidFill>
                             <a:srgbClr val="FFFFFF"/>
                           </a:solidFill>
                         </a:defRPr>
                       </a:pPr>
                       <a:r>
-                        <a:t>Hand / Reference Value</a:t>
+                        <a:t>Hand / Target</a:t>
                       </a:r>
                     </a:p>
                   </a:txBody>
@@ -4539,14 +4033,14 @@
                     <a:lstStyle/>
                     <a:p>
                       <a:pPr>
-                        <a:defRPr sz="1000" b="1">
+                        <a:defRPr sz="950" b="1">
                           <a:solidFill>
                             <a:srgbClr val="FFFFFF"/>
                           </a:solidFill>
                         </a:defRPr>
                       </a:pPr>
                       <a:r>
-                        <a:t>Physics Code Output</a:t>
+                        <a:t>Code Output</a:t>
                       </a:r>
                     </a:p>
                   </a:txBody>
@@ -4562,14 +4056,14 @@
                     <a:lstStyle/>
                     <a:p>
                       <a:pPr>
-                        <a:defRPr sz="1000" b="1">
+                        <a:defRPr sz="950" b="1">
                           <a:solidFill>
                             <a:srgbClr val="FFFFFF"/>
                           </a:solidFill>
                         </a:defRPr>
                       </a:pPr>
                       <a:r>
-                        <a:t>Error / Margin</a:t>
+                        <a:t>Difference / Tolerance</a:t>
                       </a:r>
                     </a:p>
                   </a:txBody>
@@ -4585,7 +4079,7 @@
                     <a:lstStyle/>
                     <a:p>
                       <a:pPr>
-                        <a:defRPr sz="1000" b="1">
+                        <a:defRPr sz="950" b="1">
                           <a:solidFill>
                             <a:srgbClr val="FFFFFF"/>
                           </a:solidFill>
@@ -4603,7 +4097,7 @@
                   </a:tcPr>
                 </a:tc>
               </a:tr>
-              <a:tr h="230587">
+              <a:tr h="279132">
                 <a:tc>
                   <a:txBody>
                     <a:bodyPr/>
@@ -4640,7 +4134,7 @@
                         </a:defRPr>
                       </a:pPr>
                       <a:r>
-                        <a:t>1.9840</a:t>
+                        <a:t>1.984</a:t>
                       </a:r>
                     </a:p>
                   </a:txBody>
@@ -4663,7 +4157,7 @@
                         </a:defRPr>
                       </a:pPr>
                       <a:r>
-                        <a:t>1.9840</a:t>
+                        <a:t>1.984</a:t>
                       </a:r>
                     </a:p>
                   </a:txBody>
@@ -4686,7 +4180,7 @@
                         </a:defRPr>
                       </a:pPr>
                       <a:r>
-                        <a:t>0.000%</a:t>
+                        <a:t>0.00%</a:t>
                       </a:r>
                     </a:p>
                   </a:txBody>
@@ -4720,7 +4214,7 @@
                   </a:tcPr>
                 </a:tc>
               </a:tr>
-              <a:tr h="230587">
+              <a:tr h="279132">
                 <a:tc>
                   <a:txBody>
                     <a:bodyPr/>
@@ -4803,7 +4297,7 @@
                         </a:defRPr>
                       </a:pPr>
                       <a:r>
-                        <a:t>0.019%</a:t>
+                        <a:t>0.02%</a:t>
                       </a:r>
                     </a:p>
                   </a:txBody>
@@ -4837,7 +4331,7 @@
                   </a:tcPr>
                 </a:tc>
               </a:tr>
-              <a:tr h="230587">
+              <a:tr h="279132">
                 <a:tc>
                   <a:txBody>
                     <a:bodyPr/>
@@ -4874,7 +4368,7 @@
                         </a:defRPr>
                       </a:pPr>
                       <a:r>
-                        <a:t>53.710</a:t>
+                        <a:t>53.71</a:t>
                       </a:r>
                     </a:p>
                   </a:txBody>
@@ -4897,7 +4391,7 @@
                         </a:defRPr>
                       </a:pPr>
                       <a:r>
-                        <a:t>53.709</a:t>
+                        <a:t>53.71</a:t>
                       </a:r>
                     </a:p>
                   </a:txBody>
@@ -4920,7 +4414,7 @@
                         </a:defRPr>
                       </a:pPr>
                       <a:r>
-                        <a:t>0.002%</a:t>
+                        <a:t>0.00%</a:t>
                       </a:r>
                     </a:p>
                   </a:txBody>
@@ -4954,7 +4448,7 @@
                   </a:tcPr>
                 </a:tc>
               </a:tr>
-              <a:tr h="230587">
+              <a:tr h="279132">
                 <a:tc>
                   <a:txBody>
                     <a:bodyPr/>
@@ -4968,7 +4462,7 @@
                         </a:defRPr>
                       </a:pPr>
                       <a:r>
-                        <a:t>Check 1: Outdoor Pv (kPa)</a:t>
+                        <a:t>Check 1: Mixed w (kg/kg da)</a:t>
                       </a:r>
                     </a:p>
                   </a:txBody>
@@ -4991,7 +4485,7 @@
                         </a:defRPr>
                       </a:pPr>
                       <a:r>
-                        <a:t>3.6920</a:t>
+                        <a:t>0.0158</a:t>
                       </a:r>
                     </a:p>
                   </a:txBody>
@@ -5014,7 +4508,7 @@
                         </a:defRPr>
                       </a:pPr>
                       <a:r>
-                        <a:t>3.6925</a:t>
+                        <a:t>0.0158</a:t>
                       </a:r>
                     </a:p>
                   </a:txBody>
@@ -5037,7 +4531,7 @@
                         </a:defRPr>
                       </a:pPr>
                       <a:r>
-                        <a:t>0.013%</a:t>
+                        <a:t>0.02%</a:t>
                       </a:r>
                     </a:p>
                   </a:txBody>
@@ -5071,7 +4565,7 @@
                   </a:tcPr>
                 </a:tc>
               </a:tr>
-              <a:tr h="230587">
+              <a:tr h="279132">
                 <a:tc>
                   <a:txBody>
                     <a:bodyPr/>
@@ -5085,7 +4579,7 @@
                         </a:defRPr>
                       </a:pPr>
                       <a:r>
-                        <a:t>Check 1: Outdoor w (kg/kg da)</a:t>
+                        <a:t>Check 1: Mixed h (kJ/kg da)</a:t>
                       </a:r>
                     </a:p>
                   </a:txBody>
@@ -5108,7 +4602,7 @@
                         </a:defRPr>
                       </a:pPr>
                       <a:r>
-                        <a:t>0.0235</a:t>
+                        <a:t>67.84</a:t>
                       </a:r>
                     </a:p>
                   </a:txBody>
@@ -5131,7 +4625,7 @@
                         </a:defRPr>
                       </a:pPr>
                       <a:r>
-                        <a:t>0.0235</a:t>
+                        <a:t>67.84</a:t>
                       </a:r>
                     </a:p>
                   </a:txBody>
@@ -5154,7 +4648,7 @@
                         </a:defRPr>
                       </a:pPr>
                       <a:r>
-                        <a:t>0.017%</a:t>
+                        <a:t>0.01%</a:t>
                       </a:r>
                     </a:p>
                   </a:txBody>
@@ -5188,7 +4682,7 @@
                   </a:tcPr>
                 </a:tc>
               </a:tr>
-              <a:tr h="230587">
+              <a:tr h="279132">
                 <a:tc>
                   <a:txBody>
                     <a:bodyPr/>
@@ -5202,7 +4696,7 @@
                         </a:defRPr>
                       </a:pPr>
                       <a:r>
-                        <a:t>Check 1: Outdoor h (kJ/kg da)</a:t>
+                        <a:t>Check 1: Mixed T (°C)</a:t>
                       </a:r>
                     </a:p>
                   </a:txBody>
@@ -5225,7 +4719,7 @@
                         </a:defRPr>
                       </a:pPr>
                       <a:r>
-                        <a:t>100.82</a:t>
+                        <a:t>27.48</a:t>
                       </a:r>
                     </a:p>
                   </a:txBody>
@@ -5248,7 +4742,7 @@
                         </a:defRPr>
                       </a:pPr>
                       <a:r>
-                        <a:t>100.82</a:t>
+                        <a:t>27.48</a:t>
                       </a:r>
                     </a:p>
                   </a:txBody>
@@ -5271,7 +4765,7 @@
                         </a:defRPr>
                       </a:pPr>
                       <a:r>
-                        <a:t>0.004%</a:t>
+                        <a:t>0.005 K</a:t>
                       </a:r>
                     </a:p>
                   </a:txBody>
@@ -5305,7 +4799,7 @@
                   </a:tcPr>
                 </a:tc>
               </a:tr>
-              <a:tr h="230587">
+              <a:tr h="279132">
                 <a:tc>
                   <a:txBody>
                     <a:bodyPr/>
@@ -5319,7 +4813,7 @@
                         </a:defRPr>
                       </a:pPr>
                       <a:r>
-                        <a:t>Check 1: Mixed w (kg/kg da)</a:t>
+                        <a:t>Check 1: Twb Summer Day (°C)</a:t>
                       </a:r>
                     </a:p>
                   </a:txBody>
@@ -5342,7 +4836,7 @@
                         </a:defRPr>
                       </a:pPr>
                       <a:r>
-                        <a:t>0.0158</a:t>
+                        <a:t>30.30</a:t>
                       </a:r>
                     </a:p>
                   </a:txBody>
@@ -5365,7 +4859,7 @@
                         </a:defRPr>
                       </a:pPr>
                       <a:r>
-                        <a:t>0.0158</a:t>
+                        <a:t>30.30</a:t>
                       </a:r>
                     </a:p>
                   </a:txBody>
@@ -5388,7 +4882,7 @@
                         </a:defRPr>
                       </a:pPr>
                       <a:r>
-                        <a:t>0.018%</a:t>
+                        <a:t>0.005 K</a:t>
                       </a:r>
                     </a:p>
                   </a:txBody>
@@ -5422,7 +4916,7 @@
                   </a:tcPr>
                 </a:tc>
               </a:tr>
-              <a:tr h="230587">
+              <a:tr h="279132">
                 <a:tc>
                   <a:txBody>
                     <a:bodyPr/>
@@ -5436,7 +4930,7 @@
                         </a:defRPr>
                       </a:pPr>
                       <a:r>
-                        <a:t>Check 1: Mixed h (kJ/kg da)</a:t>
+                        <a:t>Check 1: Twb Monsoon Day (°C)</a:t>
                       </a:r>
                     </a:p>
                   </a:txBody>
@@ -5459,7 +4953,7 @@
                         </a:defRPr>
                       </a:pPr>
                       <a:r>
-                        <a:t>67.840</a:t>
+                        <a:t>32.65</a:t>
                       </a:r>
                     </a:p>
                   </a:txBody>
@@ -5482,7 +4976,7 @@
                         </a:defRPr>
                       </a:pPr>
                       <a:r>
-                        <a:t>67.843</a:t>
+                        <a:t>32.65</a:t>
                       </a:r>
                     </a:p>
                   </a:txBody>
@@ -5505,7 +4999,7 @@
                         </a:defRPr>
                       </a:pPr>
                       <a:r>
-                        <a:t>0.005%</a:t>
+                        <a:t>0.002 K</a:t>
                       </a:r>
                     </a:p>
                   </a:txBody>
@@ -5539,7 +5033,7 @@
                   </a:tcPr>
                 </a:tc>
               </a:tr>
-              <a:tr h="230587">
+              <a:tr h="279132">
                 <a:tc>
                   <a:txBody>
                     <a:bodyPr/>
@@ -5553,7 +5047,7 @@
                         </a:defRPr>
                       </a:pPr>
                       <a:r>
-                        <a:t>Check 1: Mixed T (°C)</a:t>
+                        <a:t>Check 2: Psat(0 °C) (kPa)</a:t>
                       </a:r>
                     </a:p>
                   </a:txBody>
@@ -5576,7 +5070,7 @@
                         </a:defRPr>
                       </a:pPr>
                       <a:r>
-                        <a:t>27.480</a:t>
+                        <a:t>429.6</a:t>
                       </a:r>
                     </a:p>
                   </a:txBody>
@@ -5599,7 +5093,7 @@
                         </a:defRPr>
                       </a:pPr>
                       <a:r>
-                        <a:t>27.475</a:t>
+                        <a:t>424.64</a:t>
                       </a:r>
                     </a:p>
                   </a:txBody>
@@ -5622,7 +5116,7 @@
                         </a:defRPr>
                       </a:pPr>
                       <a:r>
-                        <a:t>0.005 K</a:t>
+                        <a:t>-1.15%</a:t>
                       </a:r>
                     </a:p>
                   </a:txBody>
@@ -5656,7 +5150,7 @@
                   </a:tcPr>
                 </a:tc>
               </a:tr>
-              <a:tr h="230587">
+              <a:tr h="279132">
                 <a:tc>
                   <a:txBody>
                     <a:bodyPr/>
@@ -5670,7 +5164,7 @@
                         </a:defRPr>
                       </a:pPr>
                       <a:r>
-                        <a:t>Check 1: Twb Summer Day (°C)</a:t>
+                        <a:t>Check 2: hfg(0 °C) (kJ/kg)</a:t>
                       </a:r>
                     </a:p>
                   </a:txBody>
@@ -5693,7 +5187,7 @@
                         </a:defRPr>
                       </a:pPr>
                       <a:r>
-                        <a:t>30.300</a:t>
+                        <a:t>1261.8</a:t>
                       </a:r>
                     </a:p>
                   </a:txBody>
@@ -5716,7 +5210,7 @@
                         </a:defRPr>
                       </a:pPr>
                       <a:r>
-                        <a:t>30.305</a:t>
+                        <a:t>1297.45</a:t>
                       </a:r>
                     </a:p>
                   </a:txBody>
@@ -5739,7 +5233,7 @@
                         </a:defRPr>
                       </a:pPr>
                       <a:r>
-                        <a:t>0.005 K</a:t>
+                        <a:t>+2.83%</a:t>
                       </a:r>
                     </a:p>
                   </a:txBody>
@@ -5773,7 +5267,7 @@
                   </a:tcPr>
                 </a:tc>
               </a:tr>
-              <a:tr h="230587">
+              <a:tr h="279132">
                 <a:tc>
                   <a:txBody>
                     <a:bodyPr/>
@@ -5787,7 +5281,7 @@
                         </a:defRPr>
                       </a:pPr>
                       <a:r>
-                        <a:t>Check 1: Twb Monsoon Day (°C)</a:t>
+                        <a:t>Check 2: Psat(40 °C) (kPa)</a:t>
                       </a:r>
                     </a:p>
                   </a:txBody>
@@ -5810,7 +5304,7 @@
                         </a:defRPr>
                       </a:pPr>
                       <a:r>
-                        <a:t>32.650</a:t>
+                        <a:t>1554.9</a:t>
                       </a:r>
                     </a:p>
                   </a:txBody>
@@ -5833,7 +5327,7 @@
                         </a:defRPr>
                       </a:pPr>
                       <a:r>
-                        <a:t>32.648</a:t>
+                        <a:t>1564.00</a:t>
                       </a:r>
                     </a:p>
                   </a:txBody>
@@ -5856,7 +5350,7 @@
                         </a:defRPr>
                       </a:pPr>
                       <a:r>
-                        <a:t>0.002 K</a:t>
+                        <a:t>+0.58%</a:t>
                       </a:r>
                     </a:p>
                   </a:txBody>
@@ -5890,7 +5384,7 @@
                   </a:tcPr>
                 </a:tc>
               </a:tr>
-              <a:tr h="230587">
+              <a:tr h="279132">
                 <a:tc>
                   <a:txBody>
                     <a:bodyPr/>
@@ -5904,7 +5398,7 @@
                         </a:defRPr>
                       </a:pPr>
                       <a:r>
-                        <a:t>Check 2: Psat(0 °C) (kPa)</a:t>
+                        <a:t>Check 2: hfg(40 °C) (kJ/kg)</a:t>
                       </a:r>
                     </a:p>
                   </a:txBody>
@@ -5927,7 +5421,7 @@
                         </a:defRPr>
                       </a:pPr>
                       <a:r>
-                        <a:t>429.6</a:t>
+                        <a:t>1098.8</a:t>
                       </a:r>
                     </a:p>
                   </a:txBody>
@@ -5950,7 +5444,7 @@
                         </a:defRPr>
                       </a:pPr>
                       <a:r>
-                        <a:t>424.64</a:t>
+                        <a:t>1144.95</a:t>
                       </a:r>
                     </a:p>
                   </a:txBody>
@@ -5973,7 +5467,7 @@
                         </a:defRPr>
                       </a:pPr>
                       <a:r>
-                        <a:t>-1.15%</a:t>
+                        <a:t>+4.20%</a:t>
                       </a:r>
                     </a:p>
                   </a:txBody>
@@ -6007,7 +5501,7 @@
                   </a:tcPr>
                 </a:tc>
               </a:tr>
-              <a:tr h="230587">
+              <a:tr h="279132">
                 <a:tc>
                   <a:txBody>
                     <a:bodyPr/>
@@ -6021,7 +5515,7 @@
                         </a:defRPr>
                       </a:pPr>
                       <a:r>
-                        <a:t>Check 2: hfg(0 °C) (kJ/kg)</a:t>
+                        <a:t>Check 2: qe Refrig Effect (kJ/kg)</a:t>
                       </a:r>
                     </a:p>
                   </a:txBody>
@@ -6044,7 +5538,7 @@
                         </a:defRPr>
                       </a:pPr>
                       <a:r>
-                        <a:t>1261.8</a:t>
+                        <a:t>1075.0</a:t>
                       </a:r>
                     </a:p>
                   </a:txBody>
@@ -6067,7 +5561,7 @@
                         </a:defRPr>
                       </a:pPr>
                       <a:r>
-                        <a:t>1297.45</a:t>
+                        <a:t>1098.64</a:t>
                       </a:r>
                     </a:p>
                   </a:txBody>
@@ -6090,7 +5584,7 @@
                         </a:defRPr>
                       </a:pPr>
                       <a:r>
-                        <a:t>+2.83%</a:t>
+                        <a:t>+2.20%</a:t>
                       </a:r>
                     </a:p>
                   </a:txBody>
@@ -6124,7 +5618,7 @@
                   </a:tcPr>
                 </a:tc>
               </a:tr>
-              <a:tr h="230587">
+              <a:tr h="279132">
                 <a:tc>
                   <a:txBody>
                     <a:bodyPr/>
@@ -6138,7 +5632,7 @@
                         </a:defRPr>
                       </a:pPr>
                       <a:r>
-                        <a:t>Check 2: Psat(40 °C) (kPa)</a:t>
+                        <a:t>Check 2: m_r for 5000 kW (kg/s)</a:t>
                       </a:r>
                     </a:p>
                   </a:txBody>
@@ -6161,7 +5655,7 @@
                         </a:defRPr>
                       </a:pPr>
                       <a:r>
-                        <a:t>1554.9</a:t>
+                        <a:t>4.70</a:t>
                       </a:r>
                     </a:p>
                   </a:txBody>
@@ -6184,7 +5678,7 @@
                         </a:defRPr>
                       </a:pPr>
                       <a:r>
-                        <a:t>1564.00</a:t>
+                        <a:t>4.55</a:t>
                       </a:r>
                     </a:p>
                   </a:txBody>
@@ -6207,7 +5701,7 @@
                         </a:defRPr>
                       </a:pPr>
                       <a:r>
-                        <a:t>+0.58%</a:t>
+                        <a:t>-2.13%</a:t>
                       </a:r>
                     </a:p>
                   </a:txBody>
@@ -6241,7 +5735,7 @@
                   </a:tcPr>
                 </a:tc>
               </a:tr>
-              <a:tr h="230587">
+              <a:tr h="279132">
                 <a:tc>
                   <a:txBody>
                     <a:bodyPr/>
@@ -6255,7 +5749,7 @@
                         </a:defRPr>
                       </a:pPr>
                       <a:r>
-                        <a:t>Check 2: hfg(40 °C) (kJ/kg)</a:t>
+                        <a:t>Check 3: First Law Residual (kW)</a:t>
                       </a:r>
                     </a:p>
                   </a:txBody>
@@ -6278,7 +5772,7 @@
                         </a:defRPr>
                       </a:pPr>
                       <a:r>
-                        <a:t>1098.8</a:t>
+                        <a:t>0.000</a:t>
                       </a:r>
                     </a:p>
                   </a:txBody>
@@ -6301,7 +5795,7 @@
                         </a:defRPr>
                       </a:pPr>
                       <a:r>
-                        <a:t>1144.95</a:t>
+                        <a:t>0.000</a:t>
                       </a:r>
                     </a:p>
                   </a:txBody>
@@ -6324,7 +5818,7 @@
                         </a:defRPr>
                       </a:pPr>
                       <a:r>
-                        <a:t>+4.20%</a:t>
+                        <a:t>0.00000</a:t>
                       </a:r>
                     </a:p>
                   </a:txBody>
@@ -6358,7 +5852,7 @@
                   </a:tcPr>
                 </a:tc>
               </a:tr>
-              <a:tr h="230587">
+              <a:tr h="279132">
                 <a:tc>
                   <a:txBody>
                     <a:bodyPr/>
@@ -6372,7 +5866,7 @@
                         </a:defRPr>
                       </a:pPr>
                       <a:r>
-                        <a:t>Check 2: qe Refrigerating Effect</a:t>
+                        <a:t>Check 3: Species Mass Balance (kg/s)</a:t>
                       </a:r>
                     </a:p>
                   </a:txBody>
@@ -6395,7 +5889,7 @@
                         </a:defRPr>
                       </a:pPr>
                       <a:r>
-                        <a:t>1075.0</a:t>
+                        <a:t>0.000</a:t>
                       </a:r>
                     </a:p>
                   </a:txBody>
@@ -6418,7 +5912,7 @@
                         </a:defRPr>
                       </a:pPr>
                       <a:r>
-                        <a:t>1098.64</a:t>
+                        <a:t>0.000</a:t>
                       </a:r>
                     </a:p>
                   </a:txBody>
@@ -6441,7 +5935,7 @@
                         </a:defRPr>
                       </a:pPr>
                       <a:r>
-                        <a:t>+2.20%</a:t>
+                        <a:t>0.00000</a:t>
                       </a:r>
                     </a:p>
                   </a:txBody>
@@ -6475,7 +5969,7 @@
                   </a:tcPr>
                 </a:tc>
               </a:tr>
-              <a:tr h="230587">
+              <a:tr h="279132">
                 <a:tc>
                   <a:txBody>
                     <a:bodyPr/>
@@ -6489,7 +5983,7 @@
                         </a:defRPr>
                       </a:pPr>
                       <a:r>
-                        <a:t>Check 2: m_r for 5000 kW (kg/s)</a:t>
+                        <a:t>Check 3: Carnot COP Bound</a:t>
                       </a:r>
                     </a:p>
                   </a:txBody>
@@ -6512,7 +6006,7 @@
                         </a:defRPr>
                       </a:pPr>
                       <a:r>
-                        <a:t>4.70</a:t>
+                        <a:t>1.349</a:t>
                       </a:r>
                     </a:p>
                   </a:txBody>
@@ -6535,7 +6029,7 @@
                         </a:defRPr>
                       </a:pPr>
                       <a:r>
-                        <a:t>4.55</a:t>
+                        <a:t>1.349</a:t>
                       </a:r>
                     </a:p>
                   </a:txBody>
@@ -6558,7 +6052,7 @@
                         </a:defRPr>
                       </a:pPr>
                       <a:r>
-                        <a:t>-2.13%</a:t>
+                        <a:t>0.01%</a:t>
                       </a:r>
                     </a:p>
                   </a:txBody>
@@ -6592,7 +6086,7 @@
                   </a:tcPr>
                 </a:tc>
               </a:tr>
-              <a:tr h="230587">
+              <a:tr h="279144">
                 <a:tc>
                   <a:txBody>
                     <a:bodyPr/>
@@ -6606,7 +6100,7 @@
                         </a:defRPr>
                       </a:pPr>
                       <a:r>
-                        <a:t>Check 3: First Law Residual</a:t>
+                        <a:t>Check 3: Actual COP (0.45–0.65)</a:t>
                       </a:r>
                     </a:p>
                   </a:txBody>
@@ -6629,7 +6123,7 @@
                         </a:defRPr>
                       </a:pPr>
                       <a:r>
-                        <a:t>0.000 kW</a:t>
+                        <a:t>0.550</a:t>
                       </a:r>
                     </a:p>
                   </a:txBody>
@@ -6652,7 +6146,7 @@
                         </a:defRPr>
                       </a:pPr>
                       <a:r>
-                        <a:t>0.000 kW</a:t>
+                        <a:t>0.567</a:t>
                       </a:r>
                     </a:p>
                   </a:txBody>
@@ -6675,475 +6169,7 @@
                         </a:defRPr>
                       </a:pPr>
                       <a:r>
-                        <a:t>0.000%</a:t>
-                      </a:r>
-                    </a:p>
-                  </a:txBody>
-                  <a:tcPr>
-                    <a:solidFill>
-                      <a:srgbClr val="F1F5F9"/>
-                    </a:solidFill>
-                  </a:tcPr>
-                </a:tc>
-                <a:tc>
-                  <a:txBody>
-                    <a:bodyPr/>
-                    <a:lstStyle/>
-                    <a:p>
-                      <a:pPr>
-                        <a:defRPr sz="850" b="1">
-                          <a:solidFill>
-                            <a:srgbClr val="2E7D32"/>
-                          </a:solidFill>
-                        </a:defRPr>
-                      </a:pPr>
-                      <a:r>
-                        <a:t>PASS</a:t>
-                      </a:r>
-                    </a:p>
-                  </a:txBody>
-                  <a:tcPr>
-                    <a:solidFill>
-                      <a:srgbClr val="F1F5F9"/>
-                    </a:solidFill>
-                  </a:tcPr>
-                </a:tc>
-              </a:tr>
-              <a:tr h="230587">
-                <a:tc>
-                  <a:txBody>
-                    <a:bodyPr/>
-                    <a:lstStyle/>
-                    <a:p>
-                      <a:pPr>
-                        <a:defRPr sz="850" b="1">
-                          <a:solidFill>
-                            <a:srgbClr val="102C57"/>
-                          </a:solidFill>
-                        </a:defRPr>
-                      </a:pPr>
-                      <a:r>
-                        <a:t>Check 3: Species Mass Balance</a:t>
-                      </a:r>
-                    </a:p>
-                  </a:txBody>
-                  <a:tcPr>
-                    <a:solidFill>
-                      <a:srgbClr val="FFFFFF"/>
-                    </a:solidFill>
-                  </a:tcPr>
-                </a:tc>
-                <a:tc>
-                  <a:txBody>
-                    <a:bodyPr/>
-                    <a:lstStyle/>
-                    <a:p>
-                      <a:pPr>
-                        <a:defRPr sz="850">
-                          <a:solidFill>
-                            <a:srgbClr val="212529"/>
-                          </a:solidFill>
-                        </a:defRPr>
-                      </a:pPr>
-                      <a:r>
-                        <a:t>0.000 kg/s</a:t>
-                      </a:r>
-                    </a:p>
-                  </a:txBody>
-                  <a:tcPr>
-                    <a:solidFill>
-                      <a:srgbClr val="FFFFFF"/>
-                    </a:solidFill>
-                  </a:tcPr>
-                </a:tc>
-                <a:tc>
-                  <a:txBody>
-                    <a:bodyPr/>
-                    <a:lstStyle/>
-                    <a:p>
-                      <a:pPr>
-                        <a:defRPr sz="850">
-                          <a:solidFill>
-                            <a:srgbClr val="212529"/>
-                          </a:solidFill>
-                        </a:defRPr>
-                      </a:pPr>
-                      <a:r>
-                        <a:t>0.000 kg/s</a:t>
-                      </a:r>
-                    </a:p>
-                  </a:txBody>
-                  <a:tcPr>
-                    <a:solidFill>
-                      <a:srgbClr val="FFFFFF"/>
-                    </a:solidFill>
-                  </a:tcPr>
-                </a:tc>
-                <a:tc>
-                  <a:txBody>
-                    <a:bodyPr/>
-                    <a:lstStyle/>
-                    <a:p>
-                      <a:pPr>
-                        <a:defRPr sz="850">
-                          <a:solidFill>
-                            <a:srgbClr val="212529"/>
-                          </a:solidFill>
-                        </a:defRPr>
-                      </a:pPr>
-                      <a:r>
-                        <a:t>0.000%</a:t>
-                      </a:r>
-                    </a:p>
-                  </a:txBody>
-                  <a:tcPr>
-                    <a:solidFill>
-                      <a:srgbClr val="FFFFFF"/>
-                    </a:solidFill>
-                  </a:tcPr>
-                </a:tc>
-                <a:tc>
-                  <a:txBody>
-                    <a:bodyPr/>
-                    <a:lstStyle/>
-                    <a:p>
-                      <a:pPr>
-                        <a:defRPr sz="850" b="1">
-                          <a:solidFill>
-                            <a:srgbClr val="2E7D32"/>
-                          </a:solidFill>
-                        </a:defRPr>
-                      </a:pPr>
-                      <a:r>
-                        <a:t>PASS</a:t>
-                      </a:r>
-                    </a:p>
-                  </a:txBody>
-                  <a:tcPr>
-                    <a:solidFill>
-                      <a:srgbClr val="FFFFFF"/>
-                    </a:solidFill>
-                  </a:tcPr>
-                </a:tc>
-              </a:tr>
-              <a:tr h="230587">
-                <a:tc>
-                  <a:txBody>
-                    <a:bodyPr/>
-                    <a:lstStyle/>
-                    <a:p>
-                      <a:pPr>
-                        <a:defRPr sz="850" b="1">
-                          <a:solidFill>
-                            <a:srgbClr val="102C57"/>
-                          </a:solidFill>
-                        </a:defRPr>
-                      </a:pPr>
-                      <a:r>
-                        <a:t>Check 3: Reversible COP Bound</a:t>
-                      </a:r>
-                    </a:p>
-                  </a:txBody>
-                  <a:tcPr>
-                    <a:solidFill>
-                      <a:srgbClr val="F1F5F9"/>
-                    </a:solidFill>
-                  </a:tcPr>
-                </a:tc>
-                <a:tc>
-                  <a:txBody>
-                    <a:bodyPr/>
-                    <a:lstStyle/>
-                    <a:p>
-                      <a:pPr>
-                        <a:defRPr sz="850">
-                          <a:solidFill>
-                            <a:srgbClr val="212529"/>
-                          </a:solidFill>
-                        </a:defRPr>
-                      </a:pPr>
-                      <a:r>
-                        <a:t>1.349</a:t>
-                      </a:r>
-                    </a:p>
-                  </a:txBody>
-                  <a:tcPr>
-                    <a:solidFill>
-                      <a:srgbClr val="F1F5F9"/>
-                    </a:solidFill>
-                  </a:tcPr>
-                </a:tc>
-                <a:tc>
-                  <a:txBody>
-                    <a:bodyPr/>
-                    <a:lstStyle/>
-                    <a:p>
-                      <a:pPr>
-                        <a:defRPr sz="850">
-                          <a:solidFill>
-                            <a:srgbClr val="212529"/>
-                          </a:solidFill>
-                        </a:defRPr>
-                      </a:pPr>
-                      <a:r>
-                        <a:t>1.349</a:t>
-                      </a:r>
-                    </a:p>
-                  </a:txBody>
-                  <a:tcPr>
-                    <a:solidFill>
-                      <a:srgbClr val="F1F5F9"/>
-                    </a:solidFill>
-                  </a:tcPr>
-                </a:tc>
-                <a:tc>
-                  <a:txBody>
-                    <a:bodyPr/>
-                    <a:lstStyle/>
-                    <a:p>
-                      <a:pPr>
-                        <a:defRPr sz="850">
-                          <a:solidFill>
-                            <a:srgbClr val="212529"/>
-                          </a:solidFill>
-                        </a:defRPr>
-                      </a:pPr>
-                      <a:r>
-                        <a:t>0.010%</a:t>
-                      </a:r>
-                    </a:p>
-                  </a:txBody>
-                  <a:tcPr>
-                    <a:solidFill>
-                      <a:srgbClr val="F1F5F9"/>
-                    </a:solidFill>
-                  </a:tcPr>
-                </a:tc>
-                <a:tc>
-                  <a:txBody>
-                    <a:bodyPr/>
-                    <a:lstStyle/>
-                    <a:p>
-                      <a:pPr>
-                        <a:defRPr sz="850" b="1">
-                          <a:solidFill>
-                            <a:srgbClr val="2E7D32"/>
-                          </a:solidFill>
-                        </a:defRPr>
-                      </a:pPr>
-                      <a:r>
-                        <a:t>PASS</a:t>
-                      </a:r>
-                    </a:p>
-                  </a:txBody>
-                  <a:tcPr>
-                    <a:solidFill>
-                      <a:srgbClr val="F1F5F9"/>
-                    </a:solidFill>
-                  </a:tcPr>
-                </a:tc>
-              </a:tr>
-              <a:tr h="230587">
-                <a:tc>
-                  <a:txBody>
-                    <a:bodyPr/>
-                    <a:lstStyle/>
-                    <a:p>
-                      <a:pPr>
-                        <a:defRPr sz="850" b="1">
-                          <a:solidFill>
-                            <a:srgbClr val="102C57"/>
-                          </a:solidFill>
-                        </a:defRPr>
-                      </a:pPr>
-                      <a:r>
-                        <a:t>Check 3: Machine Actual COP</a:t>
-                      </a:r>
-                    </a:p>
-                  </a:txBody>
-                  <a:tcPr>
-                    <a:solidFill>
-                      <a:srgbClr val="FFFFFF"/>
-                    </a:solidFill>
-                  </a:tcPr>
-                </a:tc>
-                <a:tc>
-                  <a:txBody>
-                    <a:bodyPr/>
-                    <a:lstStyle/>
-                    <a:p>
-                      <a:pPr>
-                        <a:defRPr sz="850">
-                          <a:solidFill>
-                            <a:srgbClr val="212529"/>
-                          </a:solidFill>
-                        </a:defRPr>
-                      </a:pPr>
-                      <a:r>
-                        <a:t>0.550</a:t>
-                      </a:r>
-                    </a:p>
-                  </a:txBody>
-                  <a:tcPr>
-                    <a:solidFill>
-                      <a:srgbClr val="FFFFFF"/>
-                    </a:solidFill>
-                  </a:tcPr>
-                </a:tc>
-                <a:tc>
-                  <a:txBody>
-                    <a:bodyPr/>
-                    <a:lstStyle/>
-                    <a:p>
-                      <a:pPr>
-                        <a:defRPr sz="850">
-                          <a:solidFill>
-                            <a:srgbClr val="212529"/>
-                          </a:solidFill>
-                        </a:defRPr>
-                      </a:pPr>
-                      <a:r>
-                        <a:t>0.531</a:t>
-                      </a:r>
-                    </a:p>
-                  </a:txBody>
-                  <a:tcPr>
-                    <a:solidFill>
-                      <a:srgbClr val="FFFFFF"/>
-                    </a:solidFill>
-                  </a:tcPr>
-                </a:tc>
-                <a:tc>
-                  <a:txBody>
-                    <a:bodyPr/>
-                    <a:lstStyle/>
-                    <a:p>
-                      <a:pPr>
-                        <a:defRPr sz="850">
-                          <a:solidFill>
-                            <a:srgbClr val="212529"/>
-                          </a:solidFill>
-                        </a:defRPr>
-                      </a:pPr>
-                      <a:r>
-                        <a:t>0.531</a:t>
-                      </a:r>
-                    </a:p>
-                  </a:txBody>
-                  <a:tcPr>
-                    <a:solidFill>
-                      <a:srgbClr val="FFFFFF"/>
-                    </a:solidFill>
-                  </a:tcPr>
-                </a:tc>
-                <a:tc>
-                  <a:txBody>
-                    <a:bodyPr/>
-                    <a:lstStyle/>
-                    <a:p>
-                      <a:pPr>
-                        <a:defRPr sz="850" b="1">
-                          <a:solidFill>
-                            <a:srgbClr val="2E7D32"/>
-                          </a:solidFill>
-                        </a:defRPr>
-                      </a:pPr>
-                      <a:r>
-                        <a:t>PASS</a:t>
-                      </a:r>
-                    </a:p>
-                  </a:txBody>
-                  <a:tcPr>
-                    <a:solidFill>
-                      <a:srgbClr val="FFFFFF"/>
-                    </a:solidFill>
-                  </a:tcPr>
-                </a:tc>
-              </a:tr>
-              <a:tr h="230606">
-                <a:tc>
-                  <a:txBody>
-                    <a:bodyPr/>
-                    <a:lstStyle/>
-                    <a:p>
-                      <a:pPr>
-                        <a:defRPr sz="850" b="1">
-                          <a:solidFill>
-                            <a:srgbClr val="102C57"/>
-                          </a:solidFill>
-                        </a:defRPr>
-                      </a:pPr>
-                      <a:r>
-                        <a:t>Check 3: COP &lt; COP_rev Bound</a:t>
-                      </a:r>
-                    </a:p>
-                  </a:txBody>
-                  <a:tcPr>
-                    <a:solidFill>
-                      <a:srgbClr val="F1F5F9"/>
-                    </a:solidFill>
-                  </a:tcPr>
-                </a:tc>
-                <a:tc>
-                  <a:txBody>
-                    <a:bodyPr/>
-                    <a:lstStyle/>
-                    <a:p>
-                      <a:pPr>
-                        <a:defRPr sz="850">
-                          <a:solidFill>
-                            <a:srgbClr val="212529"/>
-                          </a:solidFill>
-                        </a:defRPr>
-                      </a:pPr>
-                      <a:r>
-                        <a:t>TRUE</a:t>
-                      </a:r>
-                    </a:p>
-                  </a:txBody>
-                  <a:tcPr>
-                    <a:solidFill>
-                      <a:srgbClr val="F1F5F9"/>
-                    </a:solidFill>
-                  </a:tcPr>
-                </a:tc>
-                <a:tc>
-                  <a:txBody>
-                    <a:bodyPr/>
-                    <a:lstStyle/>
-                    <a:p>
-                      <a:pPr>
-                        <a:defRPr sz="850">
-                          <a:solidFill>
-                            <a:srgbClr val="212529"/>
-                          </a:solidFill>
-                        </a:defRPr>
-                      </a:pPr>
-                      <a:r>
-                        <a:t>TRUE</a:t>
-                      </a:r>
-                    </a:p>
-                  </a:txBody>
-                  <a:tcPr>
-                    <a:solidFill>
-                      <a:srgbClr val="F1F5F9"/>
-                    </a:solidFill>
-                  </a:tcPr>
-                </a:tc>
-                <a:tc>
-                  <a:txBody>
-                    <a:bodyPr/>
-                    <a:lstStyle/>
-                    <a:p>
-                      <a:pPr>
-                        <a:defRPr sz="850">
-                          <a:solidFill>
-                            <a:srgbClr val="212529"/>
-                          </a:solidFill>
-                        </a:defRPr>
-                      </a:pPr>
-                      <a:r>
-                        <a:t>TRUE</a:t>
+                        <a:t>0.567</a:t>
                       </a:r>
                     </a:p>
                   </a:txBody>
@@ -7309,14 +6335,14 @@
               </a:defRPr>
             </a:pPr>
             <a:r>
-              <a:t>Task 1: Seasonal Thermal Duties &amp; Ammonia Circuit Sizing (Baseline 30% Fresh Air)</a:t>
+              <a:t>Task 1: Seasonal Thermal Duties &amp; Psychrometric State Trajectories</a:t>
             </a:r>
           </a:p>
         </p:txBody>
       </p:sp>
       <p:pic>
         <p:nvPicPr>
-          <p:cNvPr id="5" name="Picture 4" descr="plot_seasonal_duties.png"/>
+          <p:cNvPr id="5" name="Picture 4" descr="plot_psychrometric_chart.png"/>
           <p:cNvPicPr>
             <a:picLocks noChangeAspect="1"/>
           </p:cNvPicPr>
@@ -7330,1024 +6356,38 @@
         </p:blipFill>
         <p:spPr>
           <a:xfrm>
-            <a:off x="5943600" y="1188720"/>
-            <a:ext cx="5486400" cy="3017520"/>
+            <a:off x="731520" y="1097280"/>
+            <a:ext cx="5212080" cy="3387852"/>
           </a:xfrm>
           <a:prstGeom prst="rect">
             <a:avLst/>
           </a:prstGeom>
         </p:spPr>
       </p:pic>
-      <p:graphicFrame>
-        <p:nvGraphicFramePr>
-          <p:cNvPr id="6" name="Table 5"/>
-          <p:cNvGraphicFramePr>
-            <a:graphicFrameLocks noGrp="1"/>
-          </p:cNvGraphicFramePr>
+      <p:pic>
+        <p:nvPicPr>
+          <p:cNvPr id="6" name="Picture 5" descr="plot_seasonal_duties.png"/>
+          <p:cNvPicPr>
+            <a:picLocks noChangeAspect="1"/>
+          </p:cNvPicPr>
           <p:nvPr/>
-        </p:nvGraphicFramePr>
-        <p:xfrm>
-          <a:off x="731520" y="1188720"/>
-          <a:ext cx="5029200" cy="2377440"/>
-        </p:xfrm>
-        <a:graphic>
-          <a:graphicData uri="http://schemas.openxmlformats.org/drawingml/2006/table">
-            <a:tbl>
-              <a:tblPr firstRow="1" bandRow="1">
-                <a:tableStyleId>{5C22544A-7EE6-4342-B048-85BDC9FD1C3A}</a:tableStyleId>
-              </a:tblPr>
-              <a:tblGrid>
-                <a:gridCol w="838200"/>
-                <a:gridCol w="838200"/>
-                <a:gridCol w="838200"/>
-                <a:gridCol w="838200"/>
-                <a:gridCol w="838200"/>
-                <a:gridCol w="838200"/>
-              </a:tblGrid>
-              <a:tr h="339634">
-                <a:tc>
-                  <a:txBody>
-                    <a:bodyPr/>
-                    <a:lstStyle/>
-                    <a:p>
-                      <a:pPr>
-                        <a:defRPr sz="950" b="1">
-                          <a:solidFill>
-                            <a:srgbClr val="FFFFFF"/>
-                          </a:solidFill>
-                        </a:defRPr>
-                      </a:pPr>
-                      <a:r>
-                        <a:t>Condition</a:t>
-                      </a:r>
-                    </a:p>
-                  </a:txBody>
-                  <a:tcPr>
-                    <a:solidFill>
-                      <a:srgbClr val="102C57"/>
-                    </a:solidFill>
-                  </a:tcPr>
-                </a:tc>
-                <a:tc>
-                  <a:txBody>
-                    <a:bodyPr/>
-                    <a:lstStyle/>
-                    <a:p>
-                      <a:pPr>
-                        <a:defRPr sz="950" b="1">
-                          <a:solidFill>
-                            <a:srgbClr val="FFFFFF"/>
-                          </a:solidFill>
-                        </a:defRPr>
-                      </a:pPr>
-                      <a:r>
-                        <a:t>Q_evap (kW)</a:t>
-                      </a:r>
-                    </a:p>
-                  </a:txBody>
-                  <a:tcPr>
-                    <a:solidFill>
-                      <a:srgbClr val="102C57"/>
-                    </a:solidFill>
-                  </a:tcPr>
-                </a:tc>
-                <a:tc>
-                  <a:txBody>
-                    <a:bodyPr/>
-                    <a:lstStyle/>
-                    <a:p>
-                      <a:pPr>
-                        <a:defRPr sz="950" b="1">
-                          <a:solidFill>
-                            <a:srgbClr val="FFFFFF"/>
-                          </a:solidFill>
-                        </a:defRPr>
-                      </a:pPr>
-                      <a:r>
-                        <a:t>Q_gen (kW)</a:t>
-                      </a:r>
-                    </a:p>
-                  </a:txBody>
-                  <a:tcPr>
-                    <a:solidFill>
-                      <a:srgbClr val="102C57"/>
-                    </a:solidFill>
-                  </a:tcPr>
-                </a:tc>
-                <a:tc>
-                  <a:txBody>
-                    <a:bodyPr/>
-                    <a:lstStyle/>
-                    <a:p>
-                      <a:pPr>
-                        <a:defRPr sz="950" b="1">
-                          <a:solidFill>
-                            <a:srgbClr val="FFFFFF"/>
-                          </a:solidFill>
-                        </a:defRPr>
-                      </a:pPr>
-                      <a:r>
-                        <a:t>COP</a:t>
-                      </a:r>
-                    </a:p>
-                  </a:txBody>
-                  <a:tcPr>
-                    <a:solidFill>
-                      <a:srgbClr val="102C57"/>
-                    </a:solidFill>
-                  </a:tcPr>
-                </a:tc>
-                <a:tc>
-                  <a:txBody>
-                    <a:bodyPr/>
-                    <a:lstStyle/>
-                    <a:p>
-                      <a:pPr>
-                        <a:defRPr sz="950" b="1">
-                          <a:solidFill>
-                            <a:srgbClr val="FFFFFF"/>
-                          </a:solidFill>
-                        </a:defRPr>
-                      </a:pPr>
-                      <a:r>
-                        <a:t>m_r (kg/s)</a:t>
-                      </a:r>
-                    </a:p>
-                  </a:txBody>
-                  <a:tcPr>
-                    <a:solidFill>
-                      <a:srgbClr val="102C57"/>
-                    </a:solidFill>
-                  </a:tcPr>
-                </a:tc>
-                <a:tc>
-                  <a:txBody>
-                    <a:bodyPr/>
-                    <a:lstStyle/>
-                    <a:p>
-                      <a:pPr>
-                        <a:defRPr sz="950" b="1">
-                          <a:solidFill>
-                            <a:srgbClr val="FFFFFF"/>
-                          </a:solidFill>
-                        </a:defRPr>
-                      </a:pPr>
-                      <a:r>
-                        <a:t>m_fg (kg/s)</a:t>
-                      </a:r>
-                    </a:p>
-                  </a:txBody>
-                  <a:tcPr>
-                    <a:solidFill>
-                      <a:srgbClr val="102C57"/>
-                    </a:solidFill>
-                  </a:tcPr>
-                </a:tc>
-              </a:tr>
-              <a:tr h="339634">
-                <a:tc>
-                  <a:txBody>
-                    <a:bodyPr/>
-                    <a:lstStyle/>
-                    <a:p>
-                      <a:pPr>
-                        <a:defRPr sz="900">
-                          <a:solidFill>
-                            <a:srgbClr val="212529"/>
-                          </a:solidFill>
-                        </a:defRPr>
-                      </a:pPr>
-                      <a:r>
-                        <a:t>Summer day</a:t>
-                      </a:r>
-                    </a:p>
-                  </a:txBody>
-                  <a:tcPr>
-                    <a:solidFill>
-                      <a:srgbClr val="FFFFFF"/>
-                    </a:solidFill>
-                  </a:tcPr>
-                </a:tc>
-                <a:tc>
-                  <a:txBody>
-                    <a:bodyPr/>
-                    <a:lstStyle/>
-                    <a:p>
-                      <a:pPr>
-                        <a:defRPr sz="900">
-                          <a:solidFill>
-                            <a:srgbClr val="212529"/>
-                          </a:solidFill>
-                        </a:defRPr>
-                      </a:pPr>
-                      <a:r>
-                        <a:t>4,552.9</a:t>
-                      </a:r>
-                    </a:p>
-                  </a:txBody>
-                  <a:tcPr>
-                    <a:solidFill>
-                      <a:srgbClr val="FFFFFF"/>
-                    </a:solidFill>
-                  </a:tcPr>
-                </a:tc>
-                <a:tc>
-                  <a:txBody>
-                    <a:bodyPr/>
-                    <a:lstStyle/>
-                    <a:p>
-                      <a:pPr>
-                        <a:defRPr sz="900">
-                          <a:solidFill>
-                            <a:srgbClr val="212529"/>
-                          </a:solidFill>
-                        </a:defRPr>
-                      </a:pPr>
-                      <a:r>
-                        <a:t>7,725.4</a:t>
-                      </a:r>
-                    </a:p>
-                  </a:txBody>
-                  <a:tcPr>
-                    <a:solidFill>
-                      <a:srgbClr val="FFFFFF"/>
-                    </a:solidFill>
-                  </a:tcPr>
-                </a:tc>
-                <a:tc>
-                  <a:txBody>
-                    <a:bodyPr/>
-                    <a:lstStyle/>
-                    <a:p>
-                      <a:pPr>
-                        <a:defRPr sz="900">
-                          <a:solidFill>
-                            <a:srgbClr val="212529"/>
-                          </a:solidFill>
-                        </a:defRPr>
-                      </a:pPr>
-                      <a:r>
-                        <a:t>0.588</a:t>
-                      </a:r>
-                    </a:p>
-                  </a:txBody>
-                  <a:tcPr>
-                    <a:solidFill>
-                      <a:srgbClr val="FFFFFF"/>
-                    </a:solidFill>
-                  </a:tcPr>
-                </a:tc>
-                <a:tc>
-                  <a:txBody>
-                    <a:bodyPr/>
-                    <a:lstStyle/>
-                    <a:p>
-                      <a:pPr>
-                        <a:defRPr sz="900">
-                          <a:solidFill>
-                            <a:srgbClr val="212529"/>
-                          </a:solidFill>
-                        </a:defRPr>
-                      </a:pPr>
-                      <a:r>
-                        <a:t>4.07</a:t>
-                      </a:r>
-                    </a:p>
-                  </a:txBody>
-                  <a:tcPr>
-                    <a:solidFill>
-                      <a:srgbClr val="FFFFFF"/>
-                    </a:solidFill>
-                  </a:tcPr>
-                </a:tc>
-                <a:tc>
-                  <a:txBody>
-                    <a:bodyPr/>
-                    <a:lstStyle/>
-                    <a:p>
-                      <a:pPr>
-                        <a:defRPr sz="900">
-                          <a:solidFill>
-                            <a:srgbClr val="212529"/>
-                          </a:solidFill>
-                        </a:defRPr>
-                      </a:pPr>
-                      <a:r>
-                        <a:t>55.08</a:t>
-                      </a:r>
-                    </a:p>
-                  </a:txBody>
-                  <a:tcPr>
-                    <a:solidFill>
-                      <a:srgbClr val="FFFFFF"/>
-                    </a:solidFill>
-                  </a:tcPr>
-                </a:tc>
-              </a:tr>
-              <a:tr h="339634">
-                <a:tc>
-                  <a:txBody>
-                    <a:bodyPr/>
-                    <a:lstStyle/>
-                    <a:p>
-                      <a:pPr>
-                        <a:defRPr sz="900">
-                          <a:solidFill>
-                            <a:srgbClr val="212529"/>
-                          </a:solidFill>
-                        </a:defRPr>
-                      </a:pPr>
-                      <a:r>
-                        <a:t>Summer night</a:t>
-                      </a:r>
-                    </a:p>
-                  </a:txBody>
-                  <a:tcPr>
-                    <a:solidFill>
-                      <a:srgbClr val="F1F5F9"/>
-                    </a:solidFill>
-                  </a:tcPr>
-                </a:tc>
-                <a:tc>
-                  <a:txBody>
-                    <a:bodyPr/>
-                    <a:lstStyle/>
-                    <a:p>
-                      <a:pPr>
-                        <a:defRPr sz="900">
-                          <a:solidFill>
-                            <a:srgbClr val="212529"/>
-                          </a:solidFill>
-                        </a:defRPr>
-                      </a:pPr>
-                      <a:r>
-                        <a:t>1,409.9</a:t>
-                      </a:r>
-                    </a:p>
-                  </a:txBody>
-                  <a:tcPr>
-                    <a:solidFill>
-                      <a:srgbClr val="F1F5F9"/>
-                    </a:solidFill>
-                  </a:tcPr>
-                </a:tc>
-                <a:tc>
-                  <a:txBody>
-                    <a:bodyPr/>
-                    <a:lstStyle/>
-                    <a:p>
-                      <a:pPr>
-                        <a:defRPr sz="900">
-                          <a:solidFill>
-                            <a:srgbClr val="212529"/>
-                          </a:solidFill>
-                        </a:defRPr>
-                      </a:pPr>
-                      <a:r>
-                        <a:t>2,177.4</a:t>
-                      </a:r>
-                    </a:p>
-                  </a:txBody>
-                  <a:tcPr>
-                    <a:solidFill>
-                      <a:srgbClr val="F1F5F9"/>
-                    </a:solidFill>
-                  </a:tcPr>
-                </a:tc>
-                <a:tc>
-                  <a:txBody>
-                    <a:bodyPr/>
-                    <a:lstStyle/>
-                    <a:p>
-                      <a:pPr>
-                        <a:defRPr sz="900">
-                          <a:solidFill>
-                            <a:srgbClr val="212529"/>
-                          </a:solidFill>
-                        </a:defRPr>
-                      </a:pPr>
-                      <a:r>
-                        <a:t>0.647</a:t>
-                      </a:r>
-                    </a:p>
-                  </a:txBody>
-                  <a:tcPr>
-                    <a:solidFill>
-                      <a:srgbClr val="F1F5F9"/>
-                    </a:solidFill>
-                  </a:tcPr>
-                </a:tc>
-                <a:tc>
-                  <a:txBody>
-                    <a:bodyPr/>
-                    <a:lstStyle/>
-                    <a:p>
-                      <a:pPr>
-                        <a:defRPr sz="900">
-                          <a:solidFill>
-                            <a:srgbClr val="212529"/>
-                          </a:solidFill>
-                        </a:defRPr>
-                      </a:pPr>
-                      <a:r>
-                        <a:t>1.20</a:t>
-                      </a:r>
-                    </a:p>
-                  </a:txBody>
-                  <a:tcPr>
-                    <a:solidFill>
-                      <a:srgbClr val="F1F5F9"/>
-                    </a:solidFill>
-                  </a:tcPr>
-                </a:tc>
-                <a:tc>
-                  <a:txBody>
-                    <a:bodyPr/>
-                    <a:lstStyle/>
-                    <a:p>
-                      <a:pPr>
-                        <a:defRPr sz="900">
-                          <a:solidFill>
-                            <a:srgbClr val="212529"/>
-                          </a:solidFill>
-                        </a:defRPr>
-                      </a:pPr>
-                      <a:r>
-                        <a:t>15.53</a:t>
-                      </a:r>
-                    </a:p>
-                  </a:txBody>
-                  <a:tcPr>
-                    <a:solidFill>
-                      <a:srgbClr val="F1F5F9"/>
-                    </a:solidFill>
-                  </a:tcPr>
-                </a:tc>
-              </a:tr>
-              <a:tr h="339634">
-                <a:tc>
-                  <a:txBody>
-                    <a:bodyPr/>
-                    <a:lstStyle/>
-                    <a:p>
-                      <a:pPr>
-                        <a:defRPr sz="900" b="1">
-                          <a:solidFill>
-                            <a:srgbClr val="E36414"/>
-                          </a:solidFill>
-                        </a:defRPr>
-                      </a:pPr>
-                      <a:r>
-                        <a:t>Monsoon day*</a:t>
-                      </a:r>
-                    </a:p>
-                  </a:txBody>
-                  <a:tcPr>
-                    <a:solidFill>
-                      <a:srgbClr val="FFFFFF"/>
-                    </a:solidFill>
-                  </a:tcPr>
-                </a:tc>
-                <a:tc>
-                  <a:txBody>
-                    <a:bodyPr/>
-                    <a:lstStyle/>
-                    <a:p>
-                      <a:pPr>
-                        <a:defRPr sz="900">
-                          <a:solidFill>
-                            <a:srgbClr val="212529"/>
-                          </a:solidFill>
-                        </a:defRPr>
-                      </a:pPr>
-                      <a:r>
-                        <a:t>4,908.6</a:t>
-                      </a:r>
-                    </a:p>
-                  </a:txBody>
-                  <a:tcPr>
-                    <a:solidFill>
-                      <a:srgbClr val="FFFFFF"/>
-                    </a:solidFill>
-                  </a:tcPr>
-                </a:tc>
-                <a:tc>
-                  <a:txBody>
-                    <a:bodyPr/>
-                    <a:lstStyle/>
-                    <a:p>
-                      <a:pPr>
-                        <a:defRPr sz="900">
-                          <a:solidFill>
-                            <a:srgbClr val="212529"/>
-                          </a:solidFill>
-                        </a:defRPr>
-                      </a:pPr>
-                      <a:r>
-                        <a:t>8,578.7</a:t>
-                      </a:r>
-                    </a:p>
-                  </a:txBody>
-                  <a:tcPr>
-                    <a:solidFill>
-                      <a:srgbClr val="FFFFFF"/>
-                    </a:solidFill>
-                  </a:tcPr>
-                </a:tc>
-                <a:tc>
-                  <a:txBody>
-                    <a:bodyPr/>
-                    <a:lstStyle/>
-                    <a:p>
-                      <a:pPr>
-                        <a:defRPr sz="900">
-                          <a:solidFill>
-                            <a:srgbClr val="212529"/>
-                          </a:solidFill>
-                        </a:defRPr>
-                      </a:pPr>
-                      <a:r>
-                        <a:t>0.570</a:t>
-                      </a:r>
-                    </a:p>
-                  </a:txBody>
-                  <a:tcPr>
-                    <a:solidFill>
-                      <a:srgbClr val="FFFFFF"/>
-                    </a:solidFill>
-                  </a:tcPr>
-                </a:tc>
-                <a:tc>
-                  <a:txBody>
-                    <a:bodyPr/>
-                    <a:lstStyle/>
-                    <a:p>
-                      <a:pPr>
-                        <a:defRPr sz="900">
-                          <a:solidFill>
-                            <a:srgbClr val="212529"/>
-                          </a:solidFill>
-                        </a:defRPr>
-                      </a:pPr>
-                      <a:r>
-                        <a:t>4.45</a:t>
-                      </a:r>
-                    </a:p>
-                  </a:txBody>
-                  <a:tcPr>
-                    <a:solidFill>
-                      <a:srgbClr val="FFFFFF"/>
-                    </a:solidFill>
-                  </a:tcPr>
-                </a:tc>
-                <a:tc>
-                  <a:txBody>
-                    <a:bodyPr/>
-                    <a:lstStyle/>
-                    <a:p>
-                      <a:pPr>
-                        <a:defRPr sz="900">
-                          <a:solidFill>
-                            <a:srgbClr val="212529"/>
-                          </a:solidFill>
-                        </a:defRPr>
-                      </a:pPr>
-                      <a:r>
-                        <a:t>61.17</a:t>
-                      </a:r>
-                    </a:p>
-                  </a:txBody>
-                  <a:tcPr>
-                    <a:solidFill>
-                      <a:srgbClr val="FFFFFF"/>
-                    </a:solidFill>
-                  </a:tcPr>
-                </a:tc>
-              </a:tr>
-              <a:tr h="339634">
-                <a:tc>
-                  <a:txBody>
-                    <a:bodyPr/>
-                    <a:lstStyle/>
-                    <a:p>
-                      <a:pPr>
-                        <a:defRPr sz="900">
-                          <a:solidFill>
-                            <a:srgbClr val="212529"/>
-                          </a:solidFill>
-                        </a:defRPr>
-                      </a:pPr>
-                      <a:r>
-                        <a:t>Monsoon night</a:t>
-                      </a:r>
-                    </a:p>
-                  </a:txBody>
-                  <a:tcPr>
-                    <a:solidFill>
-                      <a:srgbClr val="F1F5F9"/>
-                    </a:solidFill>
-                  </a:tcPr>
-                </a:tc>
-                <a:tc>
-                  <a:txBody>
-                    <a:bodyPr/>
-                    <a:lstStyle/>
-                    <a:p>
-                      <a:pPr>
-                        <a:defRPr sz="900">
-                          <a:solidFill>
-                            <a:srgbClr val="212529"/>
-                          </a:solidFill>
-                        </a:defRPr>
-                      </a:pPr>
-                      <a:r>
-                        <a:t>2,582.7</a:t>
-                      </a:r>
-                    </a:p>
-                  </a:txBody>
-                  <a:tcPr>
-                    <a:solidFill>
-                      <a:srgbClr val="F1F5F9"/>
-                    </a:solidFill>
-                  </a:tcPr>
-                </a:tc>
-                <a:tc>
-                  <a:txBody>
-                    <a:bodyPr/>
-                    <a:lstStyle/>
-                    <a:p>
-                      <a:pPr>
-                        <a:defRPr sz="900">
-                          <a:solidFill>
-                            <a:srgbClr val="212529"/>
-                          </a:solidFill>
-                        </a:defRPr>
-                      </a:pPr>
-                      <a:r>
-                        <a:t>4,187.2</a:t>
-                      </a:r>
-                    </a:p>
-                  </a:txBody>
-                  <a:tcPr>
-                    <a:solidFill>
-                      <a:srgbClr val="F1F5F9"/>
-                    </a:solidFill>
-                  </a:tcPr>
-                </a:tc>
-                <a:tc>
-                  <a:txBody>
-                    <a:bodyPr/>
-                    <a:lstStyle/>
-                    <a:p>
-                      <a:pPr>
-                        <a:defRPr sz="900">
-                          <a:solidFill>
-                            <a:srgbClr val="212529"/>
-                          </a:solidFill>
-                        </a:defRPr>
-                      </a:pPr>
-                      <a:r>
-                        <a:t>0.616</a:t>
-                      </a:r>
-                    </a:p>
-                  </a:txBody>
-                  <a:tcPr>
-                    <a:solidFill>
-                      <a:srgbClr val="F1F5F9"/>
-                    </a:solidFill>
-                  </a:tcPr>
-                </a:tc>
-                <a:tc>
-                  <a:txBody>
-                    <a:bodyPr/>
-                    <a:lstStyle/>
-                    <a:p>
-                      <a:pPr>
-                        <a:defRPr sz="900">
-                          <a:solidFill>
-                            <a:srgbClr val="212529"/>
-                          </a:solidFill>
-                        </a:defRPr>
-                      </a:pPr>
-                      <a:r>
-                        <a:t>2.25</a:t>
-                      </a:r>
-                    </a:p>
-                  </a:txBody>
-                  <a:tcPr>
-                    <a:solidFill>
-                      <a:srgbClr val="F1F5F9"/>
-                    </a:solidFill>
-                  </a:tcPr>
-                </a:tc>
-                <a:tc>
-                  <a:txBody>
-                    <a:bodyPr/>
-                    <a:lstStyle/>
-                    <a:p>
-                      <a:pPr>
-                        <a:defRPr sz="900">
-                          <a:solidFill>
-                            <a:srgbClr val="212529"/>
-                          </a:solidFill>
-                        </a:defRPr>
-                      </a:pPr>
-                      <a:r>
-                        <a:t>29.85</a:t>
-                      </a:r>
-                    </a:p>
-                  </a:txBody>
-                  <a:tcPr>
-                    <a:solidFill>
-                      <a:srgbClr val="F1F5F9"/>
-                    </a:solidFill>
-                  </a:tcPr>
-                </a:tc>
-              </a:tr>
-              <a:tr h="339634">
-                <a:tc>
-                  <a:txBody>
-                    <a:bodyPr/>
-                    <a:lstStyle/>
-                    <a:p>
-                      <a:pPr>
-                        <a:defRPr sz="900">
-                          <a:solidFill>
-                            <a:srgbClr val="212529"/>
-                          </a:solidFill>
-                        </a:defRPr>
-                      </a:pPr>
-                      <a:r>
-                        <a:t>Winter day</a:t>
-                      </a:r>
-                    </a:p>
-                  </a:txBody>
-                  <a:tcPr>
-                    <a:solidFill>
-                      <a:srgbClr val="FFFFFF"/>
-                    </a:solidFill>
-                  </a:tcPr>
-                </a:tc>
-                <a:tc>
-                  <a:txBody>
-                    <a:bodyPr/>
-                    <a:lstStyle/>
-                    <a:p>
-                      <a:pPr>
-                        <a:defRPr sz="900">
-                          <a:solidFill>
-                            <a:srgbClr val="212529"/>
-                          </a:solidFill>
-                        </a:defRPr>
-                      </a:pPr>
-                      <a:r>
-                        <a:t>1,817.1</a:t>
-                      </a:r>
-                    </a:p>
-                  </a:txBody>
-                  <a:tcPr>
-                    <a:solidFill>
-                      <a:srgbClr val="FFFFFF"/>
-                    </a:solidFill>
-                  </a:tcPr>
-                </a:tc>
-                <a:tc>
-                  <a:txBody>
-                    <a:bodyPr/>
-                    <a:lstStyle/>
-                    <a:p>
-                      <a:pPr>
-                        <a:defRPr sz="900">
-                          <a:solidFill>
-                            <a:srgbClr val="212529"/>
-                          </a:solidFill>
-                        </a:defRPr>
-                      </a:pPr>
-                      <a:r>
-                        <a:t>2,806.3</a:t>
-                      </a:r>
-                    </a:p>
-                  </a:txBody>
-                  <a:tcPr>
-                    <a:solidFill>
-                      <a:srgbClr val="FFFFFF"/>
-                    </a:solidFill>
-                  </a:tcPr>
-                </a:tc>
-                <a:tc>
-                  <a:txBody>
-                    <a:bodyPr/>
-                    <a:lstStyle/>
-                    <a:p>
-                      <a:pPr>
-                        <a:defRPr sz="900">
-                          <a:solidFill>
-                            <a:srgbClr val="212529"/>
-                          </a:solidFill>
-                        </a:defRPr>
-                      </a:pPr>
-                      <a:r>
-                        <a:t>0.647</a:t>
-                      </a:r>
-                    </a:p>
-                  </a:txBody>
-                  <a:tcPr>
-                    <a:solidFill>
-                      <a:srgbClr val="FFFFFF"/>
-                    </a:solidFill>
-                  </a:tcPr>
-                </a:tc>
-                <a:tc>
-                  <a:txBody>
-                    <a:bodyPr/>
-                    <a:lstStyle/>
-                    <a:p>
-                      <a:pPr>
-                        <a:defRPr sz="900">
-                          <a:solidFill>
-                            <a:srgbClr val="212529"/>
-                          </a:solidFill>
-                        </a:defRPr>
-                      </a:pPr>
-                      <a:r>
-                        <a:t>1.54</a:t>
-                      </a:r>
-                    </a:p>
-                  </a:txBody>
-                  <a:tcPr>
-                    <a:solidFill>
-                      <a:srgbClr val="FFFFFF"/>
-                    </a:solidFill>
-                  </a:tcPr>
-                </a:tc>
-                <a:tc>
-                  <a:txBody>
-                    <a:bodyPr/>
-                    <a:lstStyle/>
-                    <a:p>
-                      <a:pPr>
-                        <a:defRPr sz="900">
-                          <a:solidFill>
-                            <a:srgbClr val="212529"/>
-                          </a:solidFill>
-                        </a:defRPr>
-                      </a:pPr>
-                      <a:r>
-                        <a:t>20.01</a:t>
-                      </a:r>
-                    </a:p>
-                  </a:txBody>
-                  <a:tcPr>
-                    <a:solidFill>
-                      <a:srgbClr val="FFFFFF"/>
-                    </a:solidFill>
-                  </a:tcPr>
-                </a:tc>
-              </a:tr>
-              <a:tr h="339636">
-                <a:tc>
-                  <a:txBody>
-                    <a:bodyPr/>
-                    <a:lstStyle/>
-                    <a:p>
-                      <a:pPr>
-                        <a:defRPr sz="900" b="1">
-                          <a:solidFill>
-                            <a:srgbClr val="E36414"/>
-                          </a:solidFill>
-                        </a:defRPr>
-                      </a:pPr>
-                      <a:r>
-                        <a:t>Winter night**</a:t>
-                      </a:r>
-                    </a:p>
-                  </a:txBody>
-                  <a:tcPr>
-                    <a:solidFill>
-                      <a:srgbClr val="F1F5F9"/>
-                    </a:solidFill>
-                  </a:tcPr>
-                </a:tc>
-                <a:tc>
-                  <a:txBody>
-                    <a:bodyPr/>
-                    <a:lstStyle/>
-                    <a:p>
-                      <a:pPr>
-                        <a:defRPr sz="900">
-                          <a:solidFill>
-                            <a:srgbClr val="212529"/>
-                          </a:solidFill>
-                        </a:defRPr>
-                      </a:pPr>
-                      <a:r>
-                        <a:t>0.0</a:t>
-                      </a:r>
-                    </a:p>
-                  </a:txBody>
-                  <a:tcPr>
-                    <a:solidFill>
-                      <a:srgbClr val="F1F5F9"/>
-                    </a:solidFill>
-                  </a:tcPr>
-                </a:tc>
-                <a:tc>
-                  <a:txBody>
-                    <a:bodyPr/>
-                    <a:lstStyle/>
-                    <a:p>
-                      <a:pPr>
-                        <a:defRPr sz="900">
-                          <a:solidFill>
-                            <a:srgbClr val="212529"/>
-                          </a:solidFill>
-                        </a:defRPr>
-                      </a:pPr>
-                      <a:r>
-                        <a:t>0.0</a:t>
-                      </a:r>
-                    </a:p>
-                  </a:txBody>
-                  <a:tcPr>
-                    <a:solidFill>
-                      <a:srgbClr val="F1F5F9"/>
-                    </a:solidFill>
-                  </a:tcPr>
-                </a:tc>
-                <a:tc>
-                  <a:txBody>
-                    <a:bodyPr/>
-                    <a:lstStyle/>
-                    <a:p>
-                      <a:pPr>
-                        <a:defRPr sz="900">
-                          <a:solidFill>
-                            <a:srgbClr val="212529"/>
-                          </a:solidFill>
-                        </a:defRPr>
-                      </a:pPr>
-                      <a:r>
-                        <a:t>N/A</a:t>
-                      </a:r>
-                    </a:p>
-                  </a:txBody>
-                  <a:tcPr>
-                    <a:solidFill>
-                      <a:srgbClr val="F1F5F9"/>
-                    </a:solidFill>
-                  </a:tcPr>
-                </a:tc>
-                <a:tc>
-                  <a:txBody>
-                    <a:bodyPr/>
-                    <a:lstStyle/>
-                    <a:p>
-                      <a:pPr>
-                        <a:defRPr sz="900">
-                          <a:solidFill>
-                            <a:srgbClr val="212529"/>
-                          </a:solidFill>
-                        </a:defRPr>
-                      </a:pPr>
-                      <a:r>
-                        <a:t>0.00</a:t>
-                      </a:r>
-                    </a:p>
-                  </a:txBody>
-                  <a:tcPr>
-                    <a:solidFill>
-                      <a:srgbClr val="F1F5F9"/>
-                    </a:solidFill>
-                  </a:tcPr>
-                </a:tc>
-                <a:tc>
-                  <a:txBody>
-                    <a:bodyPr/>
-                    <a:lstStyle/>
-                    <a:p>
-                      <a:pPr>
-                        <a:defRPr sz="900">
-                          <a:solidFill>
-                            <a:srgbClr val="212529"/>
-                          </a:solidFill>
-                        </a:defRPr>
-                      </a:pPr>
-                      <a:r>
-                        <a:t>0.00</a:t>
-                      </a:r>
-                    </a:p>
-                  </a:txBody>
-                  <a:tcPr>
-                    <a:solidFill>
-                      <a:srgbClr val="F1F5F9"/>
-                    </a:solidFill>
-                  </a:tcPr>
-                </a:tc>
-              </a:tr>
-            </a:tbl>
-          </a:graphicData>
-        </a:graphic>
-      </p:graphicFrame>
+        </p:nvPicPr>
+        <p:blipFill>
+          <a:blip r:embed="rId3"/>
+          <a:stretch>
+            <a:fillRect/>
+          </a:stretch>
+        </p:blipFill>
+        <p:spPr>
+          <a:xfrm>
+            <a:off x="6217920" y="1097280"/>
+            <a:ext cx="5212080" cy="2866644"/>
+          </a:xfrm>
+          <a:prstGeom prst="rect">
+            <a:avLst/>
+          </a:prstGeom>
+        </p:spPr>
+      </p:pic>
       <p:sp>
         <p:nvSpPr>
           <p:cNvPr id="7" name="Rounded Rectangle 6"/>
@@ -8356,8 +6396,8 @@
         </p:nvSpPr>
         <p:spPr>
           <a:xfrm>
-            <a:off x="731520" y="3749039"/>
-            <a:ext cx="5029200" cy="2743200"/>
+            <a:off x="731520" y="5120640"/>
+            <a:ext cx="10728655" cy="1371600"/>
           </a:xfrm>
           <a:prstGeom prst="roundRect">
             <a:avLst/>
@@ -8390,74 +6430,74 @@
           <a:lstStyle/>
           <a:p>
             <a:pPr algn="ctr">
-              <a:defRPr sz="1200" b="1">
+              <a:defRPr sz="1100" b="1">
                 <a:solidFill>
                   <a:srgbClr val="102C57"/>
                 </a:solidFill>
               </a:defRPr>
             </a:pPr>
             <a:r>
-              <a:t>Key Physical Findings &amp; Sizing Insights:</a:t>
+              <a:t>Key Seasonal Thermodynamics Insights:</a:t>
             </a:r>
           </a:p>
           <a:p>
             <a:pPr>
               <a:spcBef>
-                <a:spcPts val="300"/>
+                <a:spcPts val="200"/>
               </a:spcBef>
-              <a:defRPr sz="950">
+              <a:defRPr sz="900">
                 <a:solidFill>
                   <a:srgbClr val="212529"/>
                 </a:solidFill>
               </a:defRPr>
             </a:pPr>
             <a:r>
-              <a:t>• *Governing Condition: Monsoon Day governs chiller size (Q_evap = 4,908.6 kW, Q_gen = 8,578.7 kW). It is NOT Summer Day (4,552.9 kW) despite Summer having a 5 °C higher dry-bulb temperature.</a:t>
+              <a:t>• Governing Peak: Monsoon Day dictates peak district chiller capacity (Q_evap = 4,908.6 kW, Q_gen = 8,193.3 kW, m_r = 4.46 kg/s). It dominates over Summer Day (4,552.9 kW) because moisture ratio w_oa = 30.6 g/kg da requires massive latent dehumidification.</a:t>
             </a:r>
           </a:p>
           <a:p>
             <a:pPr>
               <a:spcBef>
-                <a:spcPts val="300"/>
+                <a:spcPts val="200"/>
               </a:spcBef>
-              <a:defRPr sz="950">
+              <a:defRPr sz="900">
                 <a:solidFill>
                   <a:srgbClr val="212529"/>
                 </a:solidFill>
               </a:defRPr>
             </a:pPr>
             <a:r>
-              <a:t>• Physical Reason: Outdoor air in Monsoon Day carries 30.6 g/kg da of moisture (vs 23.5 g/kg in Summer). The immense latent dehumidification load on the fresh air dominates the sensible reduction.</a:t>
+              <a:t>• Latent vs Sensible: Latent load represents &gt;50% of the total cooling duty at Monsoon Day, proving that moisture management governs commercial HVAC infrastructure in hot-humid climates.</a:t>
             </a:r>
           </a:p>
           <a:p>
             <a:pPr>
               <a:spcBef>
-                <a:spcPts val="300"/>
+                <a:spcPts val="200"/>
               </a:spcBef>
-              <a:defRPr sz="950">
+              <a:defRPr sz="900">
                 <a:solidFill>
                   <a:srgbClr val="212529"/>
                 </a:solidFill>
               </a:defRPr>
             </a:pPr>
             <a:r>
-              <a:t>• Flue-Gas Envelope: Peak flue-gas flow is 61.17 kg/s, safely below the 80.0 kg/s process ceiling. Exit temperature T_fg,out = 172.5 °C stays safely above the 140 °C acid-gas dew point floor.</a:t>
+              <a:t>• Turndown &amp; Free Cooling: Winter Night load drops to 0.0 kW (&lt;25% turndown threshold = 1,227.1 kW). The absorption chiller is shut down, engaging direct waterside free cooling to eliminate boiler and pump energy consumption.</a:t>
             </a:r>
           </a:p>
           <a:p>
             <a:pPr>
               <a:spcBef>
-                <a:spcPts val="300"/>
+                <a:spcPts val="200"/>
               </a:spcBef>
-              <a:defRPr sz="950">
+              <a:defRPr sz="900">
                 <a:solidFill>
                   <a:srgbClr val="212529"/>
                 </a:solidFill>
               </a:defRPr>
             </a:pPr>
             <a:r>
-              <a:t>• **Turndown Violation: Winter night cooling demand drops to 0.0 kW (&lt;25% turndown threshold = 1,227 kW). The chiller must be staged off, utilizing direct water-side free cooling.</a:t>
+              <a:t>• Flue-Gas Envelope: Peak flue-gas demand is 56.76 kg/s (safely below 80.0 kg/s limit). Stack exit temperature is 154.5–168.8 °C (well above 140 °C acid-gas dew point floor).</a:t>
             </a:r>
           </a:p>
         </p:txBody>
@@ -8611,7 +6651,7 @@
         </p:blipFill>
         <p:spPr>
           <a:xfrm>
-            <a:off x="731520" y="1188720"/>
+            <a:off x="731520" y="1097280"/>
             <a:ext cx="5212080" cy="2369127"/>
           </a:xfrm>
           <a:prstGeom prst="rect">
@@ -8635,7 +6675,7 @@
         </p:blipFill>
         <p:spPr>
           <a:xfrm>
-            <a:off x="6217920" y="1188720"/>
+            <a:off x="6217920" y="1097280"/>
             <a:ext cx="5212080" cy="3648456"/>
           </a:xfrm>
           <a:prstGeom prst="rect">
@@ -8685,7 +6725,7 @@
           <a:lstStyle/>
           <a:p>
             <a:pPr algn="ctr">
-              <a:defRPr sz="1200" b="1">
+              <a:defRPr sz="1100" b="1">
                 <a:solidFill>
                   <a:srgbClr val="102C57"/>
                 </a:solidFill>
@@ -8700,14 +6740,14 @@
               <a:spcBef>
                 <a:spcPts val="200"/>
               </a:spcBef>
-              <a:defRPr sz="950">
+              <a:defRPr sz="900">
                 <a:solidFill>
                   <a:srgbClr val="212529"/>
                 </a:solidFill>
               </a:defRPr>
             </a:pPr>
             <a:r>
-              <a:t>1. Evaporative Condenser (RECOMMENDED): Operates against wet-bulb (Twb = 32.65 °C governing), yielding T_cond = 40.0 °C and P_high = 15.53 bar. Safe under 20.0 bar limit. High U = 600 W/m²·K requires only 1,198 m² area (UA = 718.5 kW/K). Makeup water = 373.8 m³/day at CC=4.</a:t>
+              <a:t>1. Evaporative Condenser (RECOMMENDED): Approaches wet-bulb (Twb = 32.65 °C governing), yielding T_cond = 40.0 °C and P_high = 15.64 bar. Safe under 20.0 bar vessel limit. High U = 600 W/m²·K requires 2,422 m² area (UA = 1,453.4 kW/K). Makeup water = 247.0 m³/day at CC=4.</a:t>
             </a:r>
           </a:p>
           <a:p>
@@ -8715,14 +6755,14 @@
               <a:spcBef>
                 <a:spcPts val="200"/>
               </a:spcBef>
-              <a:defRPr sz="950">
+              <a:defRPr sz="900">
                 <a:solidFill>
                   <a:srgbClr val="212529"/>
                 </a:solidFill>
               </a:defRPr>
             </a:pPr>
             <a:r>
-              <a:t>2. Air-Cooled Finned-Tube (REJECTED): Operates against dry-bulb (Tdb = 40.0 °C governing), resulting in T_cond = 52.0 °C and P_high = 21.60 bar — VIOLATES the 20 bar vessel design pressure limit! Furthermore, low U = 30 W/m²·K requires 22,400 m² (18.7x larger footprint).</a:t>
+              <a:t>2. Air-Cooled Finned-Tube (REJECTED): Approaches dry-bulb (Tdb = 40.0 °C governing), resulting in T_cond = 52.0 °C and P_high = 21.54 bar — VIOLATES the 20 bar vessel design pressure limit! Furthermore, low U = 30 W/m²·K requires 28,604 m² (11.8x larger footprint).</a:t>
             </a:r>
           </a:p>
           <a:p>
@@ -8730,14 +6770,14 @@
               <a:spcBef>
                 <a:spcPts val="200"/>
               </a:spcBef>
-              <a:defRPr sz="950">
+              <a:defRPr sz="900">
                 <a:solidFill>
                   <a:srgbClr val="212529"/>
                 </a:solidFill>
               </a:defRPr>
             </a:pPr>
             <a:r>
-              <a:t>3. Three Hard Constraints: (a) P_high ≤ 20 bar: PASSED across all conditions; (b) T_gen deliverable by 300 °C flue gas: PASSED (T_gen = 130 °C, T_fg,out = 172.5 °C ≥ 140 °C); (c) T_cond ≥ 25 °C expansion valve floor: PASSED via spray-pump head pressure control at low ambient.</a:t>
+              <a:t>3. Three Hard Constraints: (a) P_high ≤ 20 bar: PASSED across all conditions; (b) T_gen deliverable by 300 °C flue gas: PASSED (T_gen = 125.0 °C, T_fg,out = 168.8 °C ≥ 140 °C); (c) T_cond ≥ 25 °C expansion valve floor: PASSED via spray-pump head pressure control at low ambient.</a:t>
             </a:r>
           </a:p>
         </p:txBody>
@@ -8891,7 +6931,7 @@
         </p:blipFill>
         <p:spPr>
           <a:xfrm>
-            <a:off x="731520" y="1188720"/>
+            <a:off x="731520" y="1097280"/>
             <a:ext cx="5212080" cy="2710282"/>
           </a:xfrm>
           <a:prstGeom prst="rect">
@@ -8915,7 +6955,7 @@
         </p:blipFill>
         <p:spPr>
           <a:xfrm>
-            <a:off x="6217920" y="1188720"/>
+            <a:off x="6217920" y="1097280"/>
             <a:ext cx="5212080" cy="2866644"/>
           </a:xfrm>
           <a:prstGeom prst="rect">
@@ -8965,7 +7005,7 @@
           <a:lstStyle/>
           <a:p>
             <a:pPr algn="ctr">
-              <a:defRPr sz="1200" b="1">
+              <a:defRPr sz="1100" b="1">
                 <a:solidFill>
                   <a:srgbClr val="102C57"/>
                 </a:solidFill>
@@ -8980,14 +7020,14 @@
               <a:spcBef>
                 <a:spcPts val="200"/>
               </a:spcBef>
-              <a:defRPr sz="950">
+              <a:defRPr sz="900">
                 <a:solidFill>
                   <a:srgbClr val="212529"/>
                 </a:solidFill>
               </a:defRPr>
             </a:pPr>
             <a:r>
-              <a:t>• Task 3 Decanter Sizing: Monsoon Day governs central decanter holding tank capacity at 89.7 m³/day (3,738 kg/h district, 9.35 kg/h per zone). Sizing differs from the chiller because decanter load is purely latent moisture condensation, whereas chiller load includes sensible building envelope and solar gains.</a:t>
+              <a:t>• Task 3 Decanter Sizing: Monsoon Day governs central decanter holding capacity at 89.7 m³/day (3,738 kg/h district, 9.35 kg/h per zone). Sizing differs from the chiller because decanter load is purely latent moisture condensation, whereas chiller load includes sensible envelope and solar gains.</a:t>
             </a:r>
           </a:p>
           <a:p>
@@ -8995,14 +7035,14 @@
               <a:spcBef>
                 <a:spcPts val="200"/>
               </a:spcBef>
-              <a:defRPr sz="950">
+              <a:defRPr sz="900">
                 <a:solidFill>
                   <a:srgbClr val="212529"/>
                 </a:solidFill>
               </a:defRPr>
             </a:pPr>
             <a:r>
-              <a:t>• Task 4 Fresh Air Sensitivity (30% → 40%): Monsoon conditions exhibit extreme sensitivity (+19.8% coil load, +21.4% condensate rate) due to massive outdoor moisture influx. In contrast, Winter conditions exhibit negligible sensitivity (&lt;4%) because outdoor air is cool and dry.</a:t>
+              <a:t>• Task 4 Fresh Air Sensitivity (30% → 40%): Monsoon conditions exhibit extreme sensitivity (+22.2% coil load, +30.8% condensate rate) due to massive outdoor moisture influx. In contrast, Winter conditions exhibit negligible sensitivity (&lt;4%) because outdoor air is cool and dry.</a:t>
             </a:r>
           </a:p>
           <a:p>
@@ -9010,14 +7050,14 @@
               <a:spcBef>
                 <a:spcPts val="200"/>
               </a:spcBef>
-              <a:defRPr sz="950">
+              <a:defRPr sz="900">
                 <a:solidFill>
                   <a:srgbClr val="212529"/>
                 </a:solidFill>
               </a:defRPr>
             </a:pPr>
             <a:r>
-              <a:t>• Humidity Limit Violation &amp; Control Action: At Monsoon night with 40% fresh air, room RH drifts to 76.6% (&gt;75% ceiling). Remedy: Deep subcooling coil to ADP = 14.5 °C (removing moisture) followed by terminal reheat of 2.8 K, requiring an additional 410 kW of generator heat.</a:t>
+              <a:t>• Humidity Limit Violation &amp; Dynamic Reheat: At Monsoon night with 40% fresh air, room RH drifts to 76.6% (&gt;75% ceiling). Remedy: Deep subcooling coil to ADP = 15.16 °C followed by terminal reheat of ΔT = 1.19 K (1.80 kW/zone), adding 1,929.0 kW district cooling and 2,998.8 kW extra generator heat.</a:t>
             </a:r>
           </a:p>
           <a:p>
@@ -9025,14 +7065,14 @@
               <a:spcBef>
                 <a:spcPts val="200"/>
               </a:spcBef>
-              <a:defRPr sz="950">
+              <a:defRPr sz="900">
                 <a:solidFill>
                   <a:srgbClr val="212529"/>
                 </a:solidFill>
               </a:defRPr>
             </a:pPr>
             <a:r>
-              <a:t>• Pressure &amp; Flue Limits under 40% Fresh: P_high reaches 16.2 bar (≤20 bar PASS), and peak flue-gas flow reaches 73.2 kg/s (≤80 kg/s PASS).</a:t>
+              <a:t>• Pressure &amp; Flue Limits under 40% Fresh: P_high reaches 16.2 bar (≤20 bar PASS), and peak flue-gas flow reaches 71.4 kg/s (≤80 kg/s PASS).</a:t>
             </a:r>
           </a:p>
         </p:txBody>
@@ -9178,7 +7218,7 @@
         </p:nvSpPr>
         <p:spPr>
           <a:xfrm>
-            <a:off x="731520" y="1188720"/>
+            <a:off x="731520" y="1097280"/>
             <a:ext cx="5257800" cy="2514600"/>
           </a:xfrm>
           <a:prstGeom prst="roundRect">
@@ -9212,7 +7252,7 @@
           <a:lstStyle/>
           <a:p>
             <a:pPr algn="ctr">
-              <a:defRPr sz="1300" b="1">
+              <a:defRPr sz="1200" b="1">
                 <a:solidFill>
                   <a:srgbClr val="102C57"/>
                 </a:solidFill>
@@ -9225,20 +7265,20 @@
           <a:p>
             <a:pPr>
               <a:spcBef>
-                <a:spcPts val="400"/>
+                <a:spcPts val="300"/>
               </a:spcBef>
-              <a:defRPr sz="1000">
+              <a:defRPr sz="950">
                 <a:solidFill>
                   <a:srgbClr val="212529"/>
                 </a:solidFill>
               </a:defRPr>
             </a:pPr>
             <a:r>
-              <a:t>• Chiller Evaporator: Monsoon Day governs peak capacity at Q_evap = 4,908.6 kW (refrigerant flow m_r = 4.45 kg/s).</a:t>
+              <a:t>• Chiller Evaporator: Monsoon Day governs peak capacity at Q_evap = 4,908.6 kW (refrigerant flow m_r = 4.46 kg/s).</a:t>
             </a:r>
             <a:br/>
             <a:r>
-              <a:t>• Condenser Rejection: Monsoon Day governs evaporative heat rejection (Q_cond = 11,346.9 kW at Twb = 32.65 °C).</a:t>
+              <a:t>• Condenser Rejection: Monsoon Day governs evaporative heat rejection (Q_cond = 5,146.0 kW at Twb = 32.65 °C).</a:t>
             </a:r>
             <a:br/>
             <a:r>
@@ -9259,7 +7299,7 @@
         </p:nvSpPr>
         <p:spPr>
           <a:xfrm>
-            <a:off x="6172200" y="1188720"/>
+            <a:off x="6172200" y="1097280"/>
             <a:ext cx="5257800" cy="2514600"/>
           </a:xfrm>
           <a:prstGeom prst="roundRect">
@@ -9293,7 +7333,7 @@
           <a:lstStyle/>
           <a:p>
             <a:pPr algn="ctr">
-              <a:defRPr sz="1300" b="1">
+              <a:defRPr sz="1200" b="1">
                 <a:solidFill>
                   <a:srgbClr val="102C57"/>
                 </a:solidFill>
@@ -9306,20 +7346,20 @@
           <a:p>
             <a:pPr>
               <a:spcBef>
-                <a:spcPts val="400"/>
+                <a:spcPts val="300"/>
               </a:spcBef>
-              <a:defRPr sz="1000">
+              <a:defRPr sz="950">
                 <a:solidFill>
                   <a:srgbClr val="212529"/>
                 </a:solidFill>
               </a:defRPr>
             </a:pPr>
             <a:r>
-              <a:t>• Evaporative Condenser is unconditionally recommended: U = 600 W/m²·K, Area = 1,198 m², P_high = 15.53 bar.</a:t>
+              <a:t>• Evaporative Condenser is unconditionally recommended: U = 600 W/m²·K, Area = 2,422 m², P_high = 15.64 bar.</a:t>
             </a:r>
             <a:br/>
             <a:r>
-              <a:t>• Air-Cooled Finned-Tube is unviable: P_high exceeds the 20 bar vessel design ceiling (21.60 bar), and requires 22,400 m².</a:t>
+              <a:t>• Air-Cooled Finned-Tube is unviable: P_high exceeds the 20 bar vessel design ceiling (21.54 bar), and requires 28,604 m².</a:t>
             </a:r>
             <a:br/>
             <a:r>
@@ -9336,7 +7376,7 @@
         </p:nvSpPr>
         <p:spPr>
           <a:xfrm>
-            <a:off x="731520" y="3840480"/>
+            <a:off x="731520" y="3749039"/>
             <a:ext cx="5257800" cy="2514600"/>
           </a:xfrm>
           <a:prstGeom prst="roundRect">
@@ -9370,7 +7410,7 @@
           <a:lstStyle/>
           <a:p>
             <a:pPr algn="ctr">
-              <a:defRPr sz="1300" b="1">
+              <a:defRPr sz="1200" b="1">
                 <a:solidFill>
                   <a:srgbClr val="102C57"/>
                 </a:solidFill>
@@ -9383,24 +7423,24 @@
           <a:p>
             <a:pPr>
               <a:spcBef>
-                <a:spcPts val="400"/>
+                <a:spcPts val="300"/>
               </a:spcBef>
-              <a:defRPr sz="1000">
+              <a:defRPr sz="950">
                 <a:solidFill>
                   <a:srgbClr val="212529"/>
                 </a:solidFill>
               </a:defRPr>
             </a:pPr>
             <a:r>
-              <a:t>• Flue Gas Supply: Peak flow of 61.2 kg/s (30% fresh) and 73.2 kg/s (40% fresh) remains within 80.0 kg/s industrial availability.</a:t>
+              <a:t>• Flue Gas Supply: Peak flow of 56.8 kg/s (30% fresh) and 71.4 kg/s (40% fresh) remains within 80.0 kg/s industrial availability.</a:t>
             </a:r>
             <a:br/>
             <a:r>
-              <a:t>• Stack Integrity: Flue-gas exit temperature never drops below 172.5 °C, comfortably exceeding the 140 °C acid-gas floor.</a:t>
+              <a:t>• Stack Integrity: Flue-gas exit temperature never drops below 154.5 °C, comfortably exceeding the 140 °C acid-gas floor.</a:t>
             </a:r>
             <a:br/>
             <a:r>
-              <a:t>• Fresh Air Impact: Raising fresh air to 40% increases peak cooling by 17.2%; reheat is mandatory for monsoon night RH control.</a:t>
+              <a:t>• Fresh Air Impact: Raising fresh air to 40% increases peak cooling by 22.2%; terminal reheat of 1.19 K is mandatory for monsoon night RH control.</a:t>
             </a:r>
           </a:p>
         </p:txBody>
@@ -9413,7 +7453,7 @@
         </p:nvSpPr>
         <p:spPr>
           <a:xfrm>
-            <a:off x="6172200" y="3840480"/>
+            <a:off x="6172200" y="3749039"/>
             <a:ext cx="5257800" cy="2514600"/>
           </a:xfrm>
           <a:prstGeom prst="roundRect">
@@ -9447,7 +7487,7 @@
           <a:lstStyle/>
           <a:p>
             <a:pPr algn="ctr">
-              <a:defRPr sz="1300" b="1">
+              <a:defRPr sz="1200" b="1">
                 <a:solidFill>
                   <a:srgbClr val="E36414"/>
                 </a:solidFill>
@@ -9460,9 +7500,9 @@
           <a:p>
             <a:pPr>
               <a:spcBef>
-                <a:spcPts val="400"/>
+                <a:spcPts val="300"/>
               </a:spcBef>
-              <a:defRPr sz="1000">
+              <a:defRPr sz="950">
                 <a:solidFill>
                   <a:srgbClr val="212529"/>
                 </a:solidFill>
@@ -9473,15 +7513,15 @@
             </a:r>
             <a:br/>
             <a:r>
-              <a:t>  Because the ammonia-water circulation ratio f is ~3.4–4.5, sensible solution recirculation is 3.5–4.5× the refrigerant flow!</a:t>
+              <a:t>  Because the ammonia-water circulation ratio f is ~3.7, sensible solution recirculation is 3.7× the refrigerant flow!</a:t>
             </a:r>
             <a:br/>
             <a:r>
-              <a:t>  Every 5% increase in ε_SHX recovers ~450 kW of generator sensible heat directly into the strong solution stream,</a:t>
+              <a:t>  Eliminating the SHX increases generator heat demand by 3,460.5 kW (+42%), collapsing COP from 0.597 down to 0.442.</a:t>
             </a:r>
             <a:br/>
             <a:r>
-              <a:t>  boosting seasonal COP by 8–10% and reducing flue-gas demand by 4.2 kg/s. Investing in a high-performance plate SHX yields the greatest thermodynamic and economic return.</a:t>
+              <a:t>  Increasing ε_SHX from 0.70 to 0.80 saves an additional 494.4 kW of generator heat. Investing in a high-effectiveness plate SHX yields the single highest thermodynamic and financial return in the plant.</a:t>
             </a:r>
           </a:p>
         </p:txBody>

</xml_diff>